<commit_message>
Add title page and clinic name to Dr. Aishwarya Arun proposal
Title page for Kannan Prime Dental with doctor's name and date; the
clinic placeholder is replaced throughout.

Co-Authored-By: Claude Opus 5.5 <noreply@anthropic.com>
Claude-Session: https://claude.ai/code/session_016ZGbiuM9ffruZKrFMKYq5D
</commit_message>
<xml_diff>
--- a/Patientcurve-Proposal-Dr-Aishwarya-Arun.pptx
+++ b/Patientcurve-Proposal-Dr-Aishwarya-Arun.pptx
@@ -7,9 +7,10 @@
   <p:sldIdLst>
     <p:sldId id="256" r:id="rId2"/>
     <p:sldId id="257" r:id="rId3"/>
+    <p:sldId id="258" r:id="rId4"/>
   </p:sldIdLst>
   <p:notesMasterIdLst>
-    <p:notesMasterId r:id="rId4"/>
+    <p:notesMasterId r:id="rId5"/>
   </p:notesMasterIdLst>
   <p:sldSz cx="12192000" cy="6858000"/>
   <p:notesSz cx="6858000" cy="12192000"/>
@@ -615,6 +616,94 @@
             <a:fld id="{F7021451-1387-4CA6-816F-3879F97B5CBC}" type="slidenum">
               <a:rPr lang="en-US"/>
               <a:t>2</a:t>
+            </a:fld>
+            <a:endParaRPr lang="en-US"/>
+          </a:p>
+        </p:txBody>
+      </p:sp>
+    </p:spTree>
+    <p:extLst>
+      <p:ext uri="{BB962C8B-B14F-4D97-AF65-F5344CB8AC3E}">
+        <p14:creationId xmlns:p14="http://schemas.microsoft.com/office/powerpoint/2010/main" val="1024086991"/>
+      </p:ext>
+    </p:extLst>
+  </p:cSld>
+  <p:clrMapOvr>
+    <a:masterClrMapping/>
+  </p:clrMapOvr>
+</p:notes>
+</file>
+
+<file path=ppt/notesSlides/notesSlide3.xml><?xml version="1.0" encoding="utf-8"?>
+<p:notes xmlns:a="http://schemas.openxmlformats.org/drawingml/2006/main" xmlns:r="http://schemas.openxmlformats.org/officeDocument/2006/relationships" xmlns:p="http://schemas.openxmlformats.org/presentationml/2006/main">
+  <p:cSld>
+    <p:spTree>
+      <p:nvGrpSpPr>
+        <p:cNvPr id="1" name=""/>
+        <p:cNvGrpSpPr/>
+        <p:nvPr/>
+      </p:nvGrpSpPr>
+      <p:grpSpPr>
+        <a:xfrm>
+          <a:off x="0" y="0"/>
+          <a:ext cx="0" cy="0"/>
+          <a:chOff x="0" y="0"/>
+          <a:chExt cx="0" cy="0"/>
+        </a:xfrm>
+      </p:grpSpPr>
+      <p:sp>
+        <p:nvSpPr>
+          <p:cNvPr id="2" name="Slide Image Placeholder 1"/>
+          <p:cNvSpPr>
+            <a:spLocks noGrp="1" noRot="1" noChangeAspect="1"/>
+          </p:cNvSpPr>
+          <p:nvPr>
+            <p:ph type="sldImg"/>
+          </p:nvPr>
+        </p:nvSpPr>
+        <p:spPr/>
+      </p:sp>
+      <p:sp>
+        <p:nvSpPr>
+          <p:cNvPr id="3" name="Notes Placeholder 2"/>
+          <p:cNvSpPr>
+            <a:spLocks noGrp="1"/>
+          </p:cNvSpPr>
+          <p:nvPr>
+            <p:ph type="body" idx="1"/>
+          </p:nvPr>
+        </p:nvSpPr>
+        <p:spPr/>
+        <p:txBody>
+          <a:bodyPr/>
+          <a:lstStyle/>
+          <a:p>
+            <a:r>
+              <a:rPr lang="en-US" dirty="0"/>
+              <a:t/>
+            </a:r>
+            <a:endParaRPr lang="en-US" dirty="0"/>
+          </a:p>
+        </p:txBody>
+      </p:sp>
+      <p:sp>
+        <p:nvSpPr>
+          <p:cNvPr id="4" name="Slide Number Placeholder 3"/>
+          <p:cNvSpPr>
+            <a:spLocks noGrp="1"/>
+          </p:cNvSpPr>
+          <p:nvPr>
+            <p:ph type="sldNum" sz="quarter" idx="10"/>
+          </p:nvPr>
+        </p:nvSpPr>
+        <p:spPr/>
+        <p:txBody>
+          <a:bodyPr/>
+          <a:lstStyle/>
+          <a:p>
+            <a:fld id="{F7021451-1387-4CA6-816F-3879F97B5CBC}" type="slidenum">
+              <a:rPr lang="en-US"/>
+              <a:t>3</a:t>
             </a:fld>
             <a:endParaRPr lang="en-US"/>
           </a:p>
@@ -946,7 +1035,7 @@
     <p:bg>
       <p:bgPr>
         <a:solidFill>
-          <a:srgbClr val="F6F8F7"/>
+          <a:srgbClr val="14232B"/>
         </a:solidFill>
       </p:bgPr>
     </p:bg>
@@ -964,9 +1053,29 @@
           <a:chExt cx="0" cy="0"/>
         </a:xfrm>
       </p:grpSpPr>
+      <p:sp>
+        <p:nvSpPr>
+          <p:cNvPr id="2" name="Shape 0"/>
+          <p:cNvSpPr/>
+          <p:nvPr/>
+        </p:nvSpPr>
+        <p:spPr>
+          <a:xfrm>
+            <a:off x="7982712" y="0"/>
+            <a:ext cx="4208983" cy="6858000"/>
+          </a:xfrm>
+          <a:prstGeom prst="rect">
+            <a:avLst/>
+          </a:prstGeom>
+          <a:solidFill>
+            <a:srgbClr val="0E7C6B"/>
+          </a:solidFill>
+          <a:ln/>
+        </p:spPr>
+      </p:sp>
       <p:pic>
         <p:nvPicPr>
-          <p:cNvPr id="2" name="Image 0" descr="preencoded.png">    </p:cNvPr>
+          <p:cNvPr id="3" name="Image 0" descr="preencoded.png">    </p:cNvPr>
           <p:cNvPicPr>
             <a:picLocks noChangeAspect="1"/>
           </p:cNvPicPr>
@@ -980,651 +1089,17 @@
         </p:blipFill>
         <p:spPr>
           <a:xfrm>
-            <a:off x="10042855" y="384048"/>
-            <a:ext cx="1600200" cy="304800"/>
+            <a:off x="8275320" y="1234440"/>
+            <a:ext cx="3611880" cy="3611880"/>
           </a:xfrm>
           <a:prstGeom prst="rect">
             <a:avLst/>
           </a:prstGeom>
         </p:spPr>
       </p:pic>
-      <p:sp>
-        <p:nvSpPr>
-          <p:cNvPr id="3" name="Text 0"/>
-          <p:cNvSpPr txBox="1"/>
-          <p:nvPr/>
-        </p:nvSpPr>
-        <p:spPr>
-          <a:xfrm>
-            <a:off x="548640" y="347472"/>
-            <a:ext cx="8229600" cy="256032"/>
-          </a:xfrm>
-          <a:prstGeom prst="rect">
-            <a:avLst/>
-          </a:prstGeom>
-          <a:noFill/>
-          <a:ln/>
-        </p:spPr>
-        <p:txBody>
-          <a:bodyPr wrap="square" lIns="0" tIns="0" rIns="0" bIns="0" rtlCol="0" anchor="t"/>
-          <a:lstStyle/>
-          <a:p>
-            <a:pPr indent="0" marL="0">
-              <a:buNone/>
-            </a:pPr>
-            <a:r>
-              <a:rPr lang="en-US" sz="1100" b="1" spc="150" kern="0" dirty="0">
-                <a:solidFill>
-                  <a:srgbClr val="0E7C6B"/>
-                </a:solidFill>
-                <a:latin typeface="Arial" pitchFamily="34" charset="0"/>
-                <a:ea typeface="Arial" pitchFamily="34" charset="-122"/>
-                <a:cs typeface="Arial" pitchFamily="34" charset="-120"/>
-              </a:rPr>
-              <a:t>PROPOSAL FOR DR. AISHWARYA ARUN  ·  THE PROBLEM AND THE SOLUTION</a:t>
-            </a:r>
-            <a:endParaRPr lang="en-US" sz="1100" dirty="0"/>
-          </a:p>
-        </p:txBody>
-      </p:sp>
-      <p:sp>
-        <p:nvSpPr>
-          <p:cNvPr id="4" name="Text 1"/>
-          <p:cNvSpPr txBox="1"/>
-          <p:nvPr/>
-        </p:nvSpPr>
-        <p:spPr>
-          <a:xfrm>
-            <a:off x="548640" y="621792"/>
-            <a:ext cx="9144000" cy="548640"/>
-          </a:xfrm>
-          <a:prstGeom prst="rect">
-            <a:avLst/>
-          </a:prstGeom>
-          <a:noFill/>
-          <a:ln/>
-        </p:spPr>
-        <p:txBody>
-          <a:bodyPr wrap="square" lIns="0" tIns="0" rIns="0" bIns="0" rtlCol="0" anchor="t"/>
-          <a:lstStyle/>
-          <a:p>
-            <a:pPr indent="0" marL="0">
-              <a:buNone/>
-            </a:pPr>
-            <a:r>
-              <a:rPr lang="en-US" sz="2800" b="1" dirty="0">
-                <a:solidFill>
-                  <a:srgbClr val="14232B"/>
-                </a:solidFill>
-                <a:latin typeface="Arial" pitchFamily="34" charset="0"/>
-                <a:ea typeface="Arial" pitchFamily="34" charset="-122"/>
-                <a:cs typeface="Arial" pitchFamily="34" charset="-120"/>
-              </a:rPr>
-              <a:t>Every enquiry deserves a next step</a:t>
-            </a:r>
-            <a:endParaRPr lang="en-US" sz="2800" dirty="0"/>
-          </a:p>
-        </p:txBody>
-      </p:sp>
-      <p:sp>
-        <p:nvSpPr>
-          <p:cNvPr id="5" name="Shape 2"/>
-          <p:cNvSpPr/>
-          <p:nvPr/>
-        </p:nvSpPr>
-        <p:spPr>
-          <a:xfrm>
-            <a:off x="548640" y="6355080"/>
-            <a:ext cx="11094415" cy="0"/>
-          </a:xfrm>
-          <a:prstGeom prst="line">
-            <a:avLst/>
-          </a:prstGeom>
-          <a:noFill/>
-          <a:ln w="9525">
-            <a:solidFill>
-              <a:srgbClr val="D5DEDB"/>
-            </a:solidFill>
-            <a:prstDash val="solid"/>
-          </a:ln>
-        </p:spPr>
-      </p:sp>
-      <p:sp>
-        <p:nvSpPr>
-          <p:cNvPr id="6" name="Text 3"/>
-          <p:cNvSpPr txBox="1"/>
-          <p:nvPr/>
-        </p:nvSpPr>
-        <p:spPr>
-          <a:xfrm>
-            <a:off x="548640" y="6437376"/>
-            <a:ext cx="8229600" cy="237744"/>
-          </a:xfrm>
-          <a:prstGeom prst="rect">
-            <a:avLst/>
-          </a:prstGeom>
-          <a:noFill/>
-          <a:ln/>
-        </p:spPr>
-        <p:txBody>
-          <a:bodyPr wrap="square" lIns="0" tIns="0" rIns="0" bIns="0" rtlCol="0" anchor="ctr"/>
-          <a:lstStyle/>
-          <a:p>
-            <a:pPr indent="0" marL="0">
-              <a:buNone/>
-            </a:pPr>
-            <a:r>
-              <a:rPr lang="en-US" sz="1000" b="1" dirty="0">
-                <a:solidFill>
-                  <a:srgbClr val="5B6B70"/>
-                </a:solidFill>
-                <a:latin typeface="Arial" pitchFamily="34" charset="0"/>
-                <a:ea typeface="Arial" pitchFamily="34" charset="-122"/>
-                <a:cs typeface="Arial" pitchFamily="34" charset="-120"/>
-              </a:rPr>
-              <a:t>Prepared for  </a:t>
-            </a:r>
-            <a:pPr indent="0" marL="0">
-              <a:buNone/>
-            </a:pPr>
-            <a:r>
-              <a:rPr lang="en-US" sz="1000" dirty="0">
-                <a:solidFill>
-                  <a:srgbClr val="5B6B70"/>
-                </a:solidFill>
-                <a:latin typeface="Arial" pitchFamily="34" charset="0"/>
-                <a:ea typeface="Arial" pitchFamily="34" charset="-122"/>
-                <a:cs typeface="Arial" pitchFamily="34" charset="-120"/>
-              </a:rPr>
-              <a:t>Dr. Aishwarya Arun  ·  </a:t>
-            </a:r>
-            <a:pPr indent="0" marL="0">
-              <a:buNone/>
-            </a:pPr>
-            <a:r>
-              <a:rPr lang="en-US" sz="1000" b="1" dirty="0">
-                <a:solidFill>
-                  <a:srgbClr val="8F5A0E"/>
-                </a:solidFill>
-                <a:latin typeface="Arial" pitchFamily="34" charset="0"/>
-                <a:ea typeface="Arial" pitchFamily="34" charset="-122"/>
-                <a:cs typeface="Arial" pitchFamily="34" charset="-120"/>
-              </a:rPr>
-              <a:t>[Clinic name]</a:t>
-            </a:r>
-            <a:pPr indent="0" marL="0">
-              <a:buNone/>
-            </a:pPr>
-            <a:r>
-              <a:rPr lang="en-US" sz="1000" dirty="0">
-                <a:solidFill>
-                  <a:srgbClr val="5B6B70"/>
-                </a:solidFill>
-                <a:latin typeface="Arial" pitchFamily="34" charset="0"/>
-                <a:ea typeface="Arial" pitchFamily="34" charset="-122"/>
-                <a:cs typeface="Arial" pitchFamily="34" charset="-120"/>
-              </a:rPr>
-              <a:t>  ·  10 Oct 2026</a:t>
-            </a:r>
-            <a:endParaRPr lang="en-US" sz="1000" dirty="0"/>
-          </a:p>
-        </p:txBody>
-      </p:sp>
-      <p:sp>
-        <p:nvSpPr>
-          <p:cNvPr id="7" name="Text 4"/>
-          <p:cNvSpPr txBox="1"/>
-          <p:nvPr/>
-        </p:nvSpPr>
-        <p:spPr>
-          <a:xfrm>
-            <a:off x="8412480" y="6437376"/>
-            <a:ext cx="3230575" cy="237744"/>
-          </a:xfrm>
-          <a:prstGeom prst="rect">
-            <a:avLst/>
-          </a:prstGeom>
-          <a:noFill/>
-          <a:ln/>
-        </p:spPr>
-        <p:txBody>
-          <a:bodyPr wrap="square" lIns="0" tIns="0" rIns="0" bIns="0" rtlCol="0" anchor="ctr"/>
-          <a:lstStyle/>
-          <a:p>
-            <a:pPr algn="r" indent="0" marL="0">
-              <a:buNone/>
-            </a:pPr>
-            <a:r>
-              <a:rPr lang="en-US" sz="1000" dirty="0">
-                <a:solidFill>
-                  <a:srgbClr val="5B6B70"/>
-                </a:solidFill>
-                <a:latin typeface="Arial" pitchFamily="34" charset="0"/>
-                <a:ea typeface="Arial" pitchFamily="34" charset="-122"/>
-                <a:cs typeface="Arial" pitchFamily="34" charset="-120"/>
-              </a:rPr>
-              <a:t>Patientcurve proposal  ·  1 / 2</a:t>
-            </a:r>
-            <a:endParaRPr lang="en-US" sz="1000" dirty="0"/>
-          </a:p>
-        </p:txBody>
-      </p:sp>
-      <p:sp>
-        <p:nvSpPr>
-          <p:cNvPr id="8" name="Text 5"/>
-          <p:cNvSpPr txBox="1"/>
-          <p:nvPr/>
-        </p:nvSpPr>
-        <p:spPr>
-          <a:xfrm>
-            <a:off x="7223760" y="786384"/>
-            <a:ext cx="4419295" cy="475488"/>
-          </a:xfrm>
-          <a:prstGeom prst="rect">
-            <a:avLst/>
-          </a:prstGeom>
-          <a:noFill/>
-          <a:ln/>
-        </p:spPr>
-        <p:txBody>
-          <a:bodyPr wrap="square" lIns="0" tIns="0" rIns="0" bIns="0" rtlCol="0" anchor="t"/>
-          <a:lstStyle/>
-          <a:p>
-            <a:pPr algn="r" indent="0" marL="0">
-              <a:buNone/>
-            </a:pPr>
-            <a:r>
-              <a:rPr lang="en-US" sz="1250" dirty="0">
-                <a:solidFill>
-                  <a:srgbClr val="5B6B70"/>
-                </a:solidFill>
-                <a:latin typeface="Arial" pitchFamily="34" charset="0"/>
-                <a:ea typeface="Arial" pitchFamily="34" charset="-122"/>
-                <a:cs typeface="Arial" pitchFamily="34" charset="-120"/>
-              </a:rPr>
-              <a:t>Prepared for </a:t>
-            </a:r>
-            <a:pPr algn="r" indent="0" marL="0">
-              <a:buNone/>
-            </a:pPr>
-            <a:r>
-              <a:rPr lang="en-US" sz="1250" b="1" dirty="0">
-                <a:solidFill>
-                  <a:srgbClr val="14232B"/>
-                </a:solidFill>
-                <a:latin typeface="Arial" pitchFamily="34" charset="0"/>
-                <a:ea typeface="Arial" pitchFamily="34" charset="-122"/>
-                <a:cs typeface="Arial" pitchFamily="34" charset="-120"/>
-              </a:rPr>
-              <a:t>Dr. Aishwarya Arun</a:t>
-            </a:r>
-            <a:endParaRPr lang="en-US" sz="1250" dirty="0"/>
-          </a:p>
-          <a:p>
-            <a:pPr algn="r" indent="0" marL="0">
-              <a:buNone/>
-            </a:pPr>
-            <a:r>
-              <a:rPr lang="en-US" sz="1250" b="1" dirty="0">
-                <a:solidFill>
-                  <a:srgbClr val="8F5A0E"/>
-                </a:solidFill>
-                <a:latin typeface="Arial" pitchFamily="34" charset="0"/>
-                <a:ea typeface="Arial" pitchFamily="34" charset="-122"/>
-                <a:cs typeface="Arial" pitchFamily="34" charset="-120"/>
-              </a:rPr>
-              <a:t>[Clinic name]</a:t>
-            </a:r>
-            <a:pPr algn="r" indent="0" marL="0">
-              <a:buNone/>
-            </a:pPr>
-            <a:r>
-              <a:rPr lang="en-US" sz="1250" dirty="0">
-                <a:solidFill>
-                  <a:srgbClr val="5B6B70"/>
-                </a:solidFill>
-                <a:latin typeface="Arial" pitchFamily="34" charset="0"/>
-                <a:ea typeface="Arial" pitchFamily="34" charset="-122"/>
-                <a:cs typeface="Arial" pitchFamily="34" charset="-120"/>
-              </a:rPr>
-              <a:t>   ·   10 Oct 2026</a:t>
-            </a:r>
-            <a:endParaRPr lang="en-US" sz="1250" dirty="0"/>
-          </a:p>
-        </p:txBody>
-      </p:sp>
-      <p:sp>
-        <p:nvSpPr>
-          <p:cNvPr id="9" name="Shape 6"/>
-          <p:cNvSpPr/>
-          <p:nvPr/>
-        </p:nvSpPr>
-        <p:spPr>
-          <a:xfrm>
-            <a:off x="548640" y="1417320"/>
-            <a:ext cx="3611880" cy="2514600"/>
-          </a:xfrm>
-          <a:prstGeom prst="roundRect">
-            <a:avLst>
-              <a:gd name="adj" fmla="val 4364"/>
-            </a:avLst>
-          </a:prstGeom>
-          <a:solidFill>
-            <a:srgbClr val="14232B"/>
-          </a:solidFill>
-          <a:ln/>
-        </p:spPr>
-      </p:sp>
-      <p:sp>
-        <p:nvSpPr>
-          <p:cNvPr id="10" name="Text 7"/>
-          <p:cNvSpPr txBox="1"/>
-          <p:nvPr/>
-        </p:nvSpPr>
-        <p:spPr>
-          <a:xfrm>
-            <a:off x="822960" y="1645920"/>
-            <a:ext cx="3108960" cy="237744"/>
-          </a:xfrm>
-          <a:prstGeom prst="rect">
-            <a:avLst/>
-          </a:prstGeom>
-          <a:noFill/>
-          <a:ln/>
-        </p:spPr>
-        <p:txBody>
-          <a:bodyPr wrap="square" lIns="0" tIns="0" rIns="0" bIns="0" rtlCol="0" anchor="t"/>
-          <a:lstStyle/>
-          <a:p>
-            <a:pPr indent="0" marL="0">
-              <a:buNone/>
-            </a:pPr>
-            <a:r>
-              <a:rPr lang="en-US" sz="1050" b="1" spc="150" kern="0" dirty="0">
-                <a:solidFill>
-                  <a:srgbClr val="3FC0A6"/>
-                </a:solidFill>
-                <a:latin typeface="Arial" pitchFamily="34" charset="0"/>
-                <a:ea typeface="Arial" pitchFamily="34" charset="-122"/>
-                <a:cs typeface="Arial" pitchFamily="34" charset="-120"/>
-              </a:rPr>
-              <a:t>THE PROBLEM</a:t>
-            </a:r>
-            <a:endParaRPr lang="en-US" sz="1050" dirty="0"/>
-          </a:p>
-        </p:txBody>
-      </p:sp>
-      <p:sp>
-        <p:nvSpPr>
-          <p:cNvPr id="11" name="Text 8"/>
-          <p:cNvSpPr txBox="1"/>
-          <p:nvPr/>
-        </p:nvSpPr>
-        <p:spPr>
-          <a:xfrm>
-            <a:off x="822960" y="1938528"/>
-            <a:ext cx="3108960" cy="594360"/>
-          </a:xfrm>
-          <a:prstGeom prst="rect">
-            <a:avLst/>
-          </a:prstGeom>
-          <a:noFill/>
-          <a:ln/>
-        </p:spPr>
-        <p:txBody>
-          <a:bodyPr wrap="square" lIns="0" tIns="0" rIns="0" bIns="0" rtlCol="0" anchor="t"/>
-          <a:lstStyle/>
-          <a:p>
-            <a:pPr indent="0" marL="0">
-              <a:buNone/>
-            </a:pPr>
-            <a:r>
-              <a:rPr lang="en-US" sz="1450" b="1" dirty="0">
-                <a:solidFill>
-                  <a:srgbClr val="FFFFFF"/>
-                </a:solidFill>
-                <a:latin typeface="Arial" pitchFamily="34" charset="0"/>
-                <a:ea typeface="Arial" pitchFamily="34" charset="-122"/>
-                <a:cs typeface="Arial" pitchFamily="34" charset="-120"/>
-              </a:rPr>
-              <a:t>Patients don't leave. They slip away between conversations.</a:t>
-            </a:r>
-            <a:endParaRPr lang="en-US" sz="1450" dirty="0"/>
-          </a:p>
-        </p:txBody>
-      </p:sp>
-      <p:sp>
-        <p:nvSpPr>
-          <p:cNvPr id="12" name="Text 9"/>
-          <p:cNvSpPr txBox="1"/>
-          <p:nvPr/>
-        </p:nvSpPr>
-        <p:spPr>
-          <a:xfrm>
-            <a:off x="822960" y="2651760"/>
-            <a:ext cx="3108960" cy="1188720"/>
-          </a:xfrm>
-          <a:prstGeom prst="rect">
-            <a:avLst/>
-          </a:prstGeom>
-          <a:noFill/>
-          <a:ln/>
-        </p:spPr>
-        <p:txBody>
-          <a:bodyPr wrap="square" lIns="0" tIns="0" rIns="0" bIns="0" rtlCol="0" anchor="t"/>
-          <a:lstStyle/>
-          <a:p>
-            <a:pPr marL="190500" indent="-190500">
-              <a:spcAft>
-                <a:spcPts val="400"/>
-              </a:spcAft>
-              <a:buSzPct val="100000"/>
-              <a:buChar char="•"/>
-            </a:pPr>
-            <a:r>
-              <a:rPr lang="en-US" sz="1150" dirty="0">
-                <a:solidFill>
-                  <a:srgbClr val="C9D6D3"/>
-                </a:solidFill>
-                <a:latin typeface="Arial" pitchFamily="34" charset="0"/>
-                <a:ea typeface="Arial" pitchFamily="34" charset="-122"/>
-                <a:cs typeface="Arial" pitchFamily="34" charset="-120"/>
-              </a:rPr>
-              <a:t>Enquiries wait for a reply after hours or on busy days</a:t>
-            </a:r>
-            <a:endParaRPr lang="en-US" sz="1150" dirty="0"/>
-          </a:p>
-          <a:p>
-            <a:pPr marL="190500" indent="-190500">
-              <a:spcAft>
-                <a:spcPts val="400"/>
-              </a:spcAft>
-              <a:buSzPct val="100000"/>
-              <a:buChar char="•"/>
-            </a:pPr>
-            <a:r>
-              <a:rPr lang="en-US" sz="1150" dirty="0">
-                <a:solidFill>
-                  <a:srgbClr val="C9D6D3"/>
-                </a:solidFill>
-                <a:latin typeface="Arial" pitchFamily="34" charset="0"/>
-                <a:ea typeface="Arial" pitchFamily="34" charset="-122"/>
-                <a:cs typeface="Arial" pitchFamily="34" charset="-120"/>
-              </a:rPr>
-              <a:t>Patients who don't book on the first reply never hear back</a:t>
-            </a:r>
-            <a:endParaRPr lang="en-US" sz="1150" dirty="0"/>
-          </a:p>
-          <a:p>
-            <a:pPr marL="190500" indent="-190500">
-              <a:spcAft>
-                <a:spcPts val="400"/>
-              </a:spcAft>
-              <a:buSzPct val="100000"/>
-              <a:buChar char="•"/>
-            </a:pPr>
-            <a:r>
-              <a:rPr lang="en-US" sz="1150" dirty="0">
-                <a:solidFill>
-                  <a:srgbClr val="C9D6D3"/>
-                </a:solidFill>
-                <a:latin typeface="Arial" pitchFamily="34" charset="0"/>
-                <a:ea typeface="Arial" pitchFamily="34" charset="-122"/>
-                <a:cs typeface="Arial" pitchFamily="34" charset="-120"/>
-              </a:rPr>
-              <a:t>Missed visits and recalls depend on someone remembering</a:t>
-            </a:r>
-            <a:endParaRPr lang="en-US" sz="1150" dirty="0"/>
-          </a:p>
-        </p:txBody>
-      </p:sp>
-      <p:sp>
-        <p:nvSpPr>
-          <p:cNvPr id="13" name="Text 10"/>
-          <p:cNvSpPr txBox="1"/>
-          <p:nvPr/>
-        </p:nvSpPr>
-        <p:spPr>
-          <a:xfrm>
-            <a:off x="4389120" y="1417320"/>
-            <a:ext cx="6400800" cy="237744"/>
-          </a:xfrm>
-          <a:prstGeom prst="rect">
-            <a:avLst/>
-          </a:prstGeom>
-          <a:noFill/>
-          <a:ln/>
-        </p:spPr>
-        <p:txBody>
-          <a:bodyPr wrap="square" lIns="0" tIns="0" rIns="0" bIns="0" rtlCol="0" anchor="t"/>
-          <a:lstStyle/>
-          <a:p>
-            <a:pPr indent="0" marL="0">
-              <a:buNone/>
-            </a:pPr>
-            <a:r>
-              <a:rPr lang="en-US" sz="1050" b="1" spc="150" kern="0" dirty="0">
-                <a:solidFill>
-                  <a:srgbClr val="0E7C6B"/>
-                </a:solidFill>
-                <a:latin typeface="Arial" pitchFamily="34" charset="0"/>
-                <a:ea typeface="Arial" pitchFamily="34" charset="-122"/>
-                <a:cs typeface="Arial" pitchFamily="34" charset="-120"/>
-              </a:rPr>
-              <a:t>WHAT PATIENTCURVE DOES</a:t>
-            </a:r>
-            <a:endParaRPr lang="en-US" sz="1050" dirty="0"/>
-          </a:p>
-        </p:txBody>
-      </p:sp>
-      <p:sp>
-        <p:nvSpPr>
-          <p:cNvPr id="14" name="Text 11"/>
-          <p:cNvSpPr txBox="1"/>
-          <p:nvPr/>
-        </p:nvSpPr>
-        <p:spPr>
-          <a:xfrm>
-            <a:off x="4389120" y="1691640"/>
-            <a:ext cx="7253935" cy="274320"/>
-          </a:xfrm>
-          <a:prstGeom prst="rect">
-            <a:avLst/>
-          </a:prstGeom>
-          <a:noFill/>
-          <a:ln/>
-        </p:spPr>
-        <p:txBody>
-          <a:bodyPr wrap="square" lIns="0" tIns="0" rIns="0" bIns="0" rtlCol="0" anchor="t"/>
-          <a:lstStyle/>
-          <a:p>
-            <a:pPr indent="0" marL="0">
-              <a:buNone/>
-            </a:pPr>
-            <a:r>
-              <a:rPr lang="en-US" sz="1250" dirty="0">
-                <a:solidFill>
-                  <a:srgbClr val="5B6B70"/>
-                </a:solidFill>
-                <a:latin typeface="Arial" pitchFamily="34" charset="0"/>
-                <a:ea typeface="Arial" pitchFamily="34" charset="-122"/>
-                <a:cs typeface="Arial" pitchFamily="34" charset="-120"/>
-              </a:rPr>
-              <a:t>Structured WhatsApp follow-ups on the clinic's own number, using clinic-approved messages.</a:t>
-            </a:r>
-            <a:endParaRPr lang="en-US" sz="1250" dirty="0"/>
-          </a:p>
-        </p:txBody>
-      </p:sp>
-      <p:sp>
-        <p:nvSpPr>
-          <p:cNvPr id="15" name="Shape 12"/>
-          <p:cNvSpPr/>
-          <p:nvPr/>
-        </p:nvSpPr>
-        <p:spPr>
-          <a:xfrm>
-            <a:off x="4389120" y="2103120"/>
-            <a:ext cx="2296058" cy="1828800"/>
-          </a:xfrm>
-          <a:prstGeom prst="roundRect">
-            <a:avLst>
-              <a:gd name="adj" fmla="val 6000"/>
-            </a:avLst>
-          </a:prstGeom>
-          <a:solidFill>
-            <a:srgbClr val="FFFFFF"/>
-          </a:solidFill>
-          <a:ln w="9525">
-            <a:solidFill>
-              <a:srgbClr val="D5DEDB"/>
-            </a:solidFill>
-            <a:prstDash val="solid"/>
-          </a:ln>
-        </p:spPr>
-      </p:sp>
-      <p:sp>
-        <p:nvSpPr>
-          <p:cNvPr id="16" name="Text 13"/>
-          <p:cNvSpPr txBox="1"/>
-          <p:nvPr/>
-        </p:nvSpPr>
-        <p:spPr>
-          <a:xfrm>
-            <a:off x="4617720" y="2240280"/>
-            <a:ext cx="457200" cy="411480"/>
-          </a:xfrm>
-          <a:prstGeom prst="rect">
-            <a:avLst/>
-          </a:prstGeom>
-          <a:noFill/>
-          <a:ln/>
-        </p:spPr>
-        <p:txBody>
-          <a:bodyPr wrap="square" lIns="0" tIns="0" rIns="0" bIns="0" rtlCol="0" anchor="t"/>
-          <a:lstStyle/>
-          <a:p>
-            <a:pPr indent="0" marL="0">
-              <a:buNone/>
-            </a:pPr>
-            <a:r>
-              <a:rPr lang="en-US" sz="2200" b="1" dirty="0">
-                <a:solidFill>
-                  <a:srgbClr val="0E7C6B"/>
-                </a:solidFill>
-                <a:latin typeface="Arial" pitchFamily="34" charset="0"/>
-                <a:ea typeface="Arial" pitchFamily="34" charset="-122"/>
-                <a:cs typeface="Arial" pitchFamily="34" charset="-120"/>
-              </a:rPr>
-              <a:t>1</a:t>
-            </a:r>
-            <a:endParaRPr lang="en-US" sz="2200" dirty="0"/>
-          </a:p>
-        </p:txBody>
-      </p:sp>
       <p:pic>
         <p:nvPicPr>
-          <p:cNvPr id="17" name="Image 1" descr="preencoded.png">    </p:cNvPr>
+          <p:cNvPr id="4" name="Image 1" descr="preencoded.png">    </p:cNvPr>
           <p:cNvPicPr>
             <a:picLocks noChangeAspect="1"/>
           </p:cNvPicPr>
@@ -1638,8 +1113,8 @@
         </p:blipFill>
         <p:spPr>
           <a:xfrm>
-            <a:off x="6090818" y="2286000"/>
-            <a:ext cx="347472" cy="347472"/>
+            <a:off x="731520" y="731520"/>
+            <a:ext cx="2377440" cy="452846"/>
           </a:xfrm>
           <a:prstGeom prst="rect">
             <a:avLst/>
@@ -1648,14 +1123,14 @@
       </p:pic>
       <p:sp>
         <p:nvSpPr>
-          <p:cNvPr id="18" name="Text 14"/>
-          <p:cNvSpPr txBox="1"/>
-          <p:nvPr/>
-        </p:nvSpPr>
-        <p:spPr>
-          <a:xfrm>
-            <a:off x="4617720" y="2697480"/>
-            <a:ext cx="1838858" cy="320040"/>
+          <p:cNvPr id="5" name="Text 1"/>
+          <p:cNvSpPr txBox="1"/>
+          <p:nvPr/>
+        </p:nvSpPr>
+        <p:spPr>
+          <a:xfrm>
+            <a:off x="731520" y="1828800"/>
+            <a:ext cx="6949440" cy="320040"/>
           </a:xfrm>
           <a:prstGeom prst="rect">
             <a:avLst/>
@@ -1671,30 +1146,30 @@
               <a:buNone/>
             </a:pPr>
             <a:r>
-              <a:rPr lang="en-US" sz="1600" b="1" dirty="0">
-                <a:solidFill>
-                  <a:srgbClr val="14232B"/>
-                </a:solidFill>
-                <a:latin typeface="Arial" pitchFamily="34" charset="0"/>
-                <a:ea typeface="Arial" pitchFamily="34" charset="-122"/>
-                <a:cs typeface="Arial" pitchFamily="34" charset="-120"/>
-              </a:rPr>
-              <a:t>Capture</a:t>
-            </a:r>
-            <a:endParaRPr lang="en-US" sz="1600" dirty="0"/>
-          </a:p>
-        </p:txBody>
-      </p:sp>
-      <p:sp>
-        <p:nvSpPr>
-          <p:cNvPr id="19" name="Text 15"/>
-          <p:cNvSpPr txBox="1"/>
-          <p:nvPr/>
-        </p:nvSpPr>
-        <p:spPr>
-          <a:xfrm>
-            <a:off x="4617720" y="3063240"/>
-            <a:ext cx="1884578" cy="777240"/>
+              <a:rPr lang="en-US" sz="1200" b="1" spc="150" kern="0" dirty="0">
+                <a:solidFill>
+                  <a:srgbClr val="3FC0A6"/>
+                </a:solidFill>
+                <a:latin typeface="Arial" pitchFamily="34" charset="0"/>
+                <a:ea typeface="Arial" pitchFamily="34" charset="-122"/>
+                <a:cs typeface="Arial" pitchFamily="34" charset="-120"/>
+              </a:rPr>
+              <a:t>PATIENT JOURNEY AUTOMATION PROPOSAL</a:t>
+            </a:r>
+            <a:endParaRPr lang="en-US" sz="1200" dirty="0"/>
+          </a:p>
+        </p:txBody>
+      </p:sp>
+      <p:sp>
+        <p:nvSpPr>
+          <p:cNvPr id="6" name="Text 2"/>
+          <p:cNvSpPr txBox="1"/>
+          <p:nvPr/>
+        </p:nvSpPr>
+        <p:spPr>
+          <a:xfrm>
+            <a:off x="731520" y="2240280"/>
+            <a:ext cx="6949440" cy="868680"/>
           </a:xfrm>
           <a:prstGeom prst="rect">
             <a:avLst/>
@@ -1710,42 +1185,77 @@
               <a:buNone/>
             </a:pPr>
             <a:r>
-              <a:rPr lang="en-US" sz="1150" dirty="0">
-                <a:solidFill>
-                  <a:srgbClr val="5B6B70"/>
-                </a:solidFill>
-                <a:latin typeface="Arial" pitchFamily="34" charset="0"/>
-                <a:ea typeface="Arial" pitchFamily="34" charset="-122"/>
-                <a:cs typeface="Arial" pitchFamily="34" charset="-120"/>
-              </a:rPr>
-              <a:t>Every enquiry is answered and recorded with the patient's need, day or night.</a:t>
-            </a:r>
-            <a:endParaRPr lang="en-US" sz="1150" dirty="0"/>
-          </a:p>
-        </p:txBody>
-      </p:sp>
-      <p:sp>
-        <p:nvSpPr>
-          <p:cNvPr id="20" name="Shape 16"/>
+              <a:rPr lang="en-US" sz="4000" b="1" dirty="0">
+                <a:solidFill>
+                  <a:srgbClr val="FFFFFF"/>
+                </a:solidFill>
+                <a:latin typeface="Arial" pitchFamily="34" charset="0"/>
+                <a:ea typeface="Arial" pitchFamily="34" charset="-122"/>
+                <a:cs typeface="Arial" pitchFamily="34" charset="-120"/>
+              </a:rPr>
+              <a:t>Kannan Prime Dental</a:t>
+            </a:r>
+            <a:endParaRPr lang="en-US" sz="4000" dirty="0"/>
+          </a:p>
+        </p:txBody>
+      </p:sp>
+      <p:sp>
+        <p:nvSpPr>
+          <p:cNvPr id="7" name="Text 3"/>
+          <p:cNvSpPr txBox="1"/>
+          <p:nvPr/>
+        </p:nvSpPr>
+        <p:spPr>
+          <a:xfrm>
+            <a:off x="731520" y="3154680"/>
+            <a:ext cx="6766560" cy="457200"/>
+          </a:xfrm>
+          <a:prstGeom prst="rect">
+            <a:avLst/>
+          </a:prstGeom>
+          <a:noFill/>
+          <a:ln/>
+        </p:spPr>
+        <p:txBody>
+          <a:bodyPr wrap="square" lIns="0" tIns="0" rIns="0" bIns="0" rtlCol="0" anchor="t"/>
+          <a:lstStyle/>
+          <a:p>
+            <a:pPr indent="0" marL="0">
+              <a:buNone/>
+            </a:pPr>
+            <a:r>
+              <a:rPr lang="en-US" sz="1800" dirty="0">
+                <a:solidFill>
+                  <a:srgbClr val="C9D6D3"/>
+                </a:solidFill>
+                <a:latin typeface="Arial" pitchFamily="34" charset="0"/>
+                <a:ea typeface="Arial" pitchFamily="34" charset="-122"/>
+                <a:cs typeface="Arial" pitchFamily="34" charset="-120"/>
+              </a:rPr>
+              <a:t>Every enquiry deserves a next step.</a:t>
+            </a:r>
+            <a:endParaRPr lang="en-US" sz="1800" dirty="0"/>
+          </a:p>
+        </p:txBody>
+      </p:sp>
+      <p:sp>
+        <p:nvSpPr>
+          <p:cNvPr id="8" name="Shape 4"/>
           <p:cNvSpPr/>
           <p:nvPr/>
         </p:nvSpPr>
         <p:spPr>
           <a:xfrm>
-            <a:off x="6868058" y="2103120"/>
-            <a:ext cx="2296058" cy="1828800"/>
-          </a:xfrm>
-          <a:prstGeom prst="roundRect">
-            <a:avLst>
-              <a:gd name="adj" fmla="val 6000"/>
-            </a:avLst>
-          </a:prstGeom>
-          <a:solidFill>
-            <a:srgbClr val="FFFFFF"/>
-          </a:solidFill>
-          <a:ln w="9525">
+            <a:off x="731520" y="4069080"/>
+            <a:ext cx="6675120" cy="0"/>
+          </a:xfrm>
+          <a:prstGeom prst="line">
+            <a:avLst/>
+          </a:prstGeom>
+          <a:noFill/>
+          <a:ln w="12700">
             <a:solidFill>
-              <a:srgbClr val="D5DEDB"/>
+              <a:srgbClr val="2E4A55"/>
             </a:solidFill>
             <a:prstDash val="solid"/>
           </a:ln>
@@ -1753,14 +1263,14 @@
       </p:sp>
       <p:sp>
         <p:nvSpPr>
-          <p:cNvPr id="21" name="Text 17"/>
-          <p:cNvSpPr txBox="1"/>
-          <p:nvPr/>
-        </p:nvSpPr>
-        <p:spPr>
-          <a:xfrm>
-            <a:off x="7096658" y="2240280"/>
-            <a:ext cx="457200" cy="411480"/>
+          <p:cNvPr id="9" name="Text 5"/>
+          <p:cNvSpPr txBox="1"/>
+          <p:nvPr/>
+        </p:nvSpPr>
+        <p:spPr>
+          <a:xfrm>
+            <a:off x="731520" y="4297680"/>
+            <a:ext cx="2148840" cy="237744"/>
           </a:xfrm>
           <a:prstGeom prst="rect">
             <a:avLst/>
@@ -1776,54 +1286,30 @@
               <a:buNone/>
             </a:pPr>
             <a:r>
-              <a:rPr lang="en-US" sz="2200" b="1" dirty="0">
-                <a:solidFill>
-                  <a:srgbClr val="0E7C6B"/>
-                </a:solidFill>
-                <a:latin typeface="Arial" pitchFamily="34" charset="0"/>
-                <a:ea typeface="Arial" pitchFamily="34" charset="-122"/>
-                <a:cs typeface="Arial" pitchFamily="34" charset="-120"/>
-              </a:rPr>
-              <a:t>2</a:t>
-            </a:r>
-            <a:endParaRPr lang="en-US" sz="2200" dirty="0"/>
-          </a:p>
-        </p:txBody>
-      </p:sp>
-      <p:pic>
-        <p:nvPicPr>
-          <p:cNvPr id="22" name="Image 2" descr="preencoded.png">    </p:cNvPr>
-          <p:cNvPicPr>
-            <a:picLocks noChangeAspect="1"/>
-          </p:cNvPicPr>
-          <p:nvPr/>
-        </p:nvPicPr>
-        <p:blipFill>
-          <a:blip r:embed="rId3"/>
-          <a:stretch>
-            <a:fillRect/>
-          </a:stretch>
-        </p:blipFill>
-        <p:spPr>
-          <a:xfrm>
-            <a:off x="8569757" y="2286000"/>
-            <a:ext cx="347472" cy="347472"/>
-          </a:xfrm>
-          <a:prstGeom prst="rect">
-            <a:avLst/>
-          </a:prstGeom>
-        </p:spPr>
-      </p:pic>
-      <p:sp>
-        <p:nvSpPr>
-          <p:cNvPr id="23" name="Text 18"/>
-          <p:cNvSpPr txBox="1"/>
-          <p:nvPr/>
-        </p:nvSpPr>
-        <p:spPr>
-          <a:xfrm>
-            <a:off x="7096658" y="2697480"/>
-            <a:ext cx="1838858" cy="320040"/>
+              <a:rPr lang="en-US" sz="1000" b="1" spc="150" kern="0" dirty="0">
+                <a:solidFill>
+                  <a:srgbClr val="3FC0A6"/>
+                </a:solidFill>
+                <a:latin typeface="Arial" pitchFamily="34" charset="0"/>
+                <a:ea typeface="Arial" pitchFamily="34" charset="-122"/>
+                <a:cs typeface="Arial" pitchFamily="34" charset="-120"/>
+              </a:rPr>
+              <a:t>PREPARED FOR</a:t>
+            </a:r>
+            <a:endParaRPr lang="en-US" sz="1000" dirty="0"/>
+          </a:p>
+        </p:txBody>
+      </p:sp>
+      <p:sp>
+        <p:nvSpPr>
+          <p:cNvPr id="10" name="Text 6"/>
+          <p:cNvSpPr txBox="1"/>
+          <p:nvPr/>
+        </p:nvSpPr>
+        <p:spPr>
+          <a:xfrm>
+            <a:off x="731520" y="4572000"/>
+            <a:ext cx="2148840" cy="548640"/>
           </a:xfrm>
           <a:prstGeom prst="rect">
             <a:avLst/>
@@ -1839,30 +1325,30 @@
               <a:buNone/>
             </a:pPr>
             <a:r>
-              <a:rPr lang="en-US" sz="1600" b="1" dirty="0">
-                <a:solidFill>
-                  <a:srgbClr val="14232B"/>
-                </a:solidFill>
-                <a:latin typeface="Arial" pitchFamily="34" charset="0"/>
-                <a:ea typeface="Arial" pitchFamily="34" charset="-122"/>
-                <a:cs typeface="Arial" pitchFamily="34" charset="-120"/>
-              </a:rPr>
-              <a:t>Follow up</a:t>
-            </a:r>
-            <a:endParaRPr lang="en-US" sz="1600" dirty="0"/>
-          </a:p>
-        </p:txBody>
-      </p:sp>
-      <p:sp>
-        <p:nvSpPr>
-          <p:cNvPr id="24" name="Text 19"/>
-          <p:cNvSpPr txBox="1"/>
-          <p:nvPr/>
-        </p:nvSpPr>
-        <p:spPr>
-          <a:xfrm>
-            <a:off x="7096658" y="3063240"/>
-            <a:ext cx="1884578" cy="777240"/>
+              <a:rPr lang="en-US" sz="1500" b="1" dirty="0">
+                <a:solidFill>
+                  <a:srgbClr val="FFFFFF"/>
+                </a:solidFill>
+                <a:latin typeface="Arial" pitchFamily="34" charset="0"/>
+                <a:ea typeface="Arial" pitchFamily="34" charset="-122"/>
+                <a:cs typeface="Arial" pitchFamily="34" charset="-120"/>
+              </a:rPr>
+              <a:t>Dr. Aishwarya Arun</a:t>
+            </a:r>
+            <a:endParaRPr lang="en-US" sz="1500" dirty="0"/>
+          </a:p>
+        </p:txBody>
+      </p:sp>
+      <p:sp>
+        <p:nvSpPr>
+          <p:cNvPr id="11" name="Text 7"/>
+          <p:cNvSpPr txBox="1"/>
+          <p:nvPr/>
+        </p:nvSpPr>
+        <p:spPr>
+          <a:xfrm>
+            <a:off x="3017520" y="4297680"/>
+            <a:ext cx="2148840" cy="237744"/>
           </a:xfrm>
           <a:prstGeom prst="rect">
             <a:avLst/>
@@ -1878,57 +1364,30 @@
               <a:buNone/>
             </a:pPr>
             <a:r>
-              <a:rPr lang="en-US" sz="1150" dirty="0">
-                <a:solidFill>
-                  <a:srgbClr val="5B6B70"/>
-                </a:solidFill>
-                <a:latin typeface="Arial" pitchFamily="34" charset="0"/>
-                <a:ea typeface="Arial" pitchFamily="34" charset="-122"/>
-                <a:cs typeface="Arial" pitchFamily="34" charset="-120"/>
-              </a:rPr>
-              <a:t>Timed follow-ups and reminders until the patient books or opts out.</a:t>
-            </a:r>
-            <a:endParaRPr lang="en-US" sz="1150" dirty="0"/>
-          </a:p>
-        </p:txBody>
-      </p:sp>
-      <p:sp>
-        <p:nvSpPr>
-          <p:cNvPr id="25" name="Shape 20"/>
-          <p:cNvSpPr/>
-          <p:nvPr/>
-        </p:nvSpPr>
-        <p:spPr>
-          <a:xfrm>
-            <a:off x="9346997" y="2103120"/>
-            <a:ext cx="2296058" cy="1828800"/>
-          </a:xfrm>
-          <a:prstGeom prst="roundRect">
-            <a:avLst>
-              <a:gd name="adj" fmla="val 6000"/>
-            </a:avLst>
-          </a:prstGeom>
-          <a:solidFill>
-            <a:srgbClr val="DCEFEA"/>
-          </a:solidFill>
-          <a:ln w="9525">
-            <a:solidFill>
-              <a:srgbClr val="0E7C6B"/>
-            </a:solidFill>
-            <a:prstDash val="solid"/>
-          </a:ln>
-        </p:spPr>
-      </p:sp>
-      <p:sp>
-        <p:nvSpPr>
-          <p:cNvPr id="26" name="Text 21"/>
-          <p:cNvSpPr txBox="1"/>
-          <p:nvPr/>
-        </p:nvSpPr>
-        <p:spPr>
-          <a:xfrm>
-            <a:off x="9575597" y="2240280"/>
-            <a:ext cx="457200" cy="411480"/>
+              <a:rPr lang="en-US" sz="1000" b="1" spc="150" kern="0" dirty="0">
+                <a:solidFill>
+                  <a:srgbClr val="3FC0A6"/>
+                </a:solidFill>
+                <a:latin typeface="Arial" pitchFamily="34" charset="0"/>
+                <a:ea typeface="Arial" pitchFamily="34" charset="-122"/>
+                <a:cs typeface="Arial" pitchFamily="34" charset="-120"/>
+              </a:rPr>
+              <a:t>CLINIC</a:t>
+            </a:r>
+            <a:endParaRPr lang="en-US" sz="1000" dirty="0"/>
+          </a:p>
+        </p:txBody>
+      </p:sp>
+      <p:sp>
+        <p:nvSpPr>
+          <p:cNvPr id="12" name="Text 8"/>
+          <p:cNvSpPr txBox="1"/>
+          <p:nvPr/>
+        </p:nvSpPr>
+        <p:spPr>
+          <a:xfrm>
+            <a:off x="3017520" y="4572000"/>
+            <a:ext cx="2148840" cy="548640"/>
           </a:xfrm>
           <a:prstGeom prst="rect">
             <a:avLst/>
@@ -1944,54 +1403,30 @@
               <a:buNone/>
             </a:pPr>
             <a:r>
-              <a:rPr lang="en-US" sz="2200" b="1" dirty="0">
-                <a:solidFill>
-                  <a:srgbClr val="0E7C6B"/>
-                </a:solidFill>
-                <a:latin typeface="Arial" pitchFamily="34" charset="0"/>
-                <a:ea typeface="Arial" pitchFamily="34" charset="-122"/>
-                <a:cs typeface="Arial" pitchFamily="34" charset="-120"/>
-              </a:rPr>
-              <a:t>3</a:t>
-            </a:r>
-            <a:endParaRPr lang="en-US" sz="2200" dirty="0"/>
-          </a:p>
-        </p:txBody>
-      </p:sp>
-      <p:pic>
-        <p:nvPicPr>
-          <p:cNvPr id="27" name="Image 3" descr="preencoded.png">    </p:cNvPr>
-          <p:cNvPicPr>
-            <a:picLocks noChangeAspect="1"/>
-          </p:cNvPicPr>
-          <p:nvPr/>
-        </p:nvPicPr>
-        <p:blipFill>
-          <a:blip r:embed="rId4"/>
-          <a:stretch>
-            <a:fillRect/>
-          </a:stretch>
-        </p:blipFill>
-        <p:spPr>
-          <a:xfrm>
-            <a:off x="11048695" y="2286000"/>
-            <a:ext cx="347472" cy="347472"/>
-          </a:xfrm>
-          <a:prstGeom prst="rect">
-            <a:avLst/>
-          </a:prstGeom>
-        </p:spPr>
-      </p:pic>
-      <p:sp>
-        <p:nvSpPr>
-          <p:cNvPr id="28" name="Text 22"/>
-          <p:cNvSpPr txBox="1"/>
-          <p:nvPr/>
-        </p:nvSpPr>
-        <p:spPr>
-          <a:xfrm>
-            <a:off x="9575597" y="2697480"/>
-            <a:ext cx="1838858" cy="320040"/>
+              <a:rPr lang="en-US" sz="1500" b="1" dirty="0">
+                <a:solidFill>
+                  <a:srgbClr val="FFFFFF"/>
+                </a:solidFill>
+                <a:latin typeface="Arial" pitchFamily="34" charset="0"/>
+                <a:ea typeface="Arial" pitchFamily="34" charset="-122"/>
+                <a:cs typeface="Arial" pitchFamily="34" charset="-120"/>
+              </a:rPr>
+              <a:t>Kannan Prime Dental</a:t>
+            </a:r>
+            <a:endParaRPr lang="en-US" sz="1500" dirty="0"/>
+          </a:p>
+        </p:txBody>
+      </p:sp>
+      <p:sp>
+        <p:nvSpPr>
+          <p:cNvPr id="13" name="Text 9"/>
+          <p:cNvSpPr txBox="1"/>
+          <p:nvPr/>
+        </p:nvSpPr>
+        <p:spPr>
+          <a:xfrm>
+            <a:off x="5303520" y="4297680"/>
+            <a:ext cx="2148840" cy="237744"/>
           </a:xfrm>
           <a:prstGeom prst="rect">
             <a:avLst/>
@@ -2007,30 +1442,30 @@
               <a:buNone/>
             </a:pPr>
             <a:r>
-              <a:rPr lang="en-US" sz="1600" b="1" dirty="0">
-                <a:solidFill>
-                  <a:srgbClr val="14232B"/>
-                </a:solidFill>
-                <a:latin typeface="Arial" pitchFamily="34" charset="0"/>
-                <a:ea typeface="Arial" pitchFamily="34" charset="-122"/>
-                <a:cs typeface="Arial" pitchFamily="34" charset="-120"/>
-              </a:rPr>
-              <a:t>Recover</a:t>
-            </a:r>
-            <a:endParaRPr lang="en-US" sz="1600" dirty="0"/>
-          </a:p>
-        </p:txBody>
-      </p:sp>
-      <p:sp>
-        <p:nvSpPr>
-          <p:cNvPr id="29" name="Text 23"/>
-          <p:cNvSpPr txBox="1"/>
-          <p:nvPr/>
-        </p:nvSpPr>
-        <p:spPr>
-          <a:xfrm>
-            <a:off x="9575597" y="3063240"/>
-            <a:ext cx="1884578" cy="777240"/>
+              <a:rPr lang="en-US" sz="1000" b="1" spc="150" kern="0" dirty="0">
+                <a:solidFill>
+                  <a:srgbClr val="3FC0A6"/>
+                </a:solidFill>
+                <a:latin typeface="Arial" pitchFamily="34" charset="0"/>
+                <a:ea typeface="Arial" pitchFamily="34" charset="-122"/>
+                <a:cs typeface="Arial" pitchFamily="34" charset="-120"/>
+              </a:rPr>
+              <a:t>DATE</a:t>
+            </a:r>
+            <a:endParaRPr lang="en-US" sz="1000" dirty="0"/>
+          </a:p>
+        </p:txBody>
+      </p:sp>
+      <p:sp>
+        <p:nvSpPr>
+          <p:cNvPr id="14" name="Text 10"/>
+          <p:cNvSpPr txBox="1"/>
+          <p:nvPr/>
+        </p:nvSpPr>
+        <p:spPr>
+          <a:xfrm>
+            <a:off x="5303520" y="4572000"/>
+            <a:ext cx="2148840" cy="548640"/>
           </a:xfrm>
           <a:prstGeom prst="rect">
             <a:avLst/>
@@ -2046,30 +1481,30 @@
               <a:buNone/>
             </a:pPr>
             <a:r>
-              <a:rPr lang="en-US" sz="1150" dirty="0">
-                <a:solidFill>
-                  <a:srgbClr val="5B6B70"/>
-                </a:solidFill>
-                <a:latin typeface="Arial" pitchFamily="34" charset="0"/>
-                <a:ea typeface="Arial" pitchFamily="34" charset="-122"/>
-                <a:cs typeface="Arial" pitchFamily="34" charset="-120"/>
-              </a:rPr>
-              <a:t>Missed visits and past patients are invited back where appointment data allows.</a:t>
-            </a:r>
-            <a:endParaRPr lang="en-US" sz="1150" dirty="0"/>
-          </a:p>
-        </p:txBody>
-      </p:sp>
-      <p:sp>
-        <p:nvSpPr>
-          <p:cNvPr id="30" name="Text 24"/>
-          <p:cNvSpPr txBox="1"/>
-          <p:nvPr/>
-        </p:nvSpPr>
-        <p:spPr>
-          <a:xfrm>
-            <a:off x="548640" y="4160520"/>
-            <a:ext cx="5486400" cy="237744"/>
+              <a:rPr lang="en-US" sz="1500" b="1" dirty="0">
+                <a:solidFill>
+                  <a:srgbClr val="FFFFFF"/>
+                </a:solidFill>
+                <a:latin typeface="Arial" pitchFamily="34" charset="0"/>
+                <a:ea typeface="Arial" pitchFamily="34" charset="-122"/>
+                <a:cs typeface="Arial" pitchFamily="34" charset="-120"/>
+              </a:rPr>
+              <a:t>10 Oct 2026</a:t>
+            </a:r>
+            <a:endParaRPr lang="en-US" sz="1500" dirty="0"/>
+          </a:p>
+        </p:txBody>
+      </p:sp>
+      <p:sp>
+        <p:nvSpPr>
+          <p:cNvPr id="15" name="Text 11"/>
+          <p:cNvSpPr txBox="1"/>
+          <p:nvPr/>
+        </p:nvSpPr>
+        <p:spPr>
+          <a:xfrm>
+            <a:off x="731520" y="5989320"/>
+            <a:ext cx="6766560" cy="320040"/>
           </a:xfrm>
           <a:prstGeom prst="rect">
             <a:avLst/>
@@ -2085,820 +1520,15 @@
               <a:buNone/>
             </a:pPr>
             <a:r>
-              <a:rPr lang="en-US" sz="1050" b="1" spc="150" kern="0" dirty="0">
-                <a:solidFill>
-                  <a:srgbClr val="0E7C6B"/>
-                </a:solidFill>
-                <a:latin typeface="Arial" pitchFamily="34" charset="0"/>
-                <a:ea typeface="Arial" pitchFamily="34" charset="-122"/>
-                <a:cs typeface="Arial" pitchFamily="34" charset="-120"/>
-              </a:rPr>
-              <a:t>HOW IT WORKS</a:t>
-            </a:r>
-            <a:endParaRPr lang="en-US" sz="1050" dirty="0"/>
-          </a:p>
-        </p:txBody>
-      </p:sp>
-      <p:sp>
-        <p:nvSpPr>
-          <p:cNvPr id="31" name="Shape 25"/>
-          <p:cNvSpPr/>
-          <p:nvPr/>
-        </p:nvSpPr>
-        <p:spPr>
-          <a:xfrm>
-            <a:off x="548640" y="4434840"/>
-            <a:ext cx="1999427" cy="566928"/>
-          </a:xfrm>
-          <a:prstGeom prst="roundRect">
-            <a:avLst>
-              <a:gd name="adj" fmla="val 19355"/>
-            </a:avLst>
-          </a:prstGeom>
-          <a:solidFill>
-            <a:srgbClr val="FFFFFF"/>
-          </a:solidFill>
-          <a:ln w="9525">
-            <a:solidFill>
-              <a:srgbClr val="D5DEDB"/>
-            </a:solidFill>
-            <a:prstDash val="solid"/>
-          </a:ln>
-        </p:spPr>
-      </p:sp>
-      <p:sp>
-        <p:nvSpPr>
-          <p:cNvPr id="32" name="Text 26"/>
-          <p:cNvSpPr txBox="1"/>
-          <p:nvPr/>
-        </p:nvSpPr>
-        <p:spPr>
-          <a:xfrm>
-            <a:off x="658368" y="4434840"/>
-            <a:ext cx="1779971" cy="566928"/>
-          </a:xfrm>
-          <a:prstGeom prst="rect">
-            <a:avLst/>
-          </a:prstGeom>
-          <a:noFill/>
-          <a:ln/>
-        </p:spPr>
-        <p:txBody>
-          <a:bodyPr wrap="square" lIns="0" tIns="0" rIns="0" bIns="0" rtlCol="0" anchor="ctr"/>
-          <a:lstStyle/>
-          <a:p>
-            <a:pPr algn="ctr" indent="0" marL="0">
-              <a:buNone/>
-            </a:pPr>
-            <a:r>
-              <a:rPr lang="en-US" sz="1150" b="1" dirty="0">
-                <a:solidFill>
-                  <a:srgbClr val="14232B"/>
-                </a:solidFill>
-                <a:latin typeface="Arial" pitchFamily="34" charset="0"/>
-                <a:ea typeface="Arial" pitchFamily="34" charset="-122"/>
-                <a:cs typeface="Arial" pitchFamily="34" charset="-120"/>
-              </a:rPr>
-              <a:t>Patient messages on WhatsApp</a:t>
-            </a:r>
-            <a:endParaRPr lang="en-US" sz="1150" dirty="0"/>
-          </a:p>
-        </p:txBody>
-      </p:sp>
-      <p:sp>
-        <p:nvSpPr>
-          <p:cNvPr id="33" name="Shape 27"/>
-          <p:cNvSpPr/>
-          <p:nvPr/>
-        </p:nvSpPr>
-        <p:spPr>
-          <a:xfrm>
-            <a:off x="2584643" y="4718304"/>
-            <a:ext cx="201168" cy="0"/>
-          </a:xfrm>
-          <a:prstGeom prst="line">
-            <a:avLst/>
-          </a:prstGeom>
-          <a:noFill/>
-          <a:ln w="19050">
-            <a:solidFill>
-              <a:srgbClr val="0E7C6B"/>
-            </a:solidFill>
-            <a:prstDash val="solid"/>
-            <a:tailEnd type="triangle"/>
-          </a:ln>
-        </p:spPr>
-      </p:sp>
-      <p:sp>
-        <p:nvSpPr>
-          <p:cNvPr id="34" name="Shape 28"/>
-          <p:cNvSpPr/>
-          <p:nvPr/>
-        </p:nvSpPr>
-        <p:spPr>
-          <a:xfrm>
-            <a:off x="2822387" y="4434840"/>
-            <a:ext cx="1999427" cy="566928"/>
-          </a:xfrm>
-          <a:prstGeom prst="roundRect">
-            <a:avLst>
-              <a:gd name="adj" fmla="val 19355"/>
-            </a:avLst>
-          </a:prstGeom>
-          <a:solidFill>
-            <a:srgbClr val="FFFFFF"/>
-          </a:solidFill>
-          <a:ln w="9525">
-            <a:solidFill>
-              <a:srgbClr val="D5DEDB"/>
-            </a:solidFill>
-            <a:prstDash val="solid"/>
-          </a:ln>
-        </p:spPr>
-      </p:sp>
-      <p:sp>
-        <p:nvSpPr>
-          <p:cNvPr id="35" name="Text 29"/>
-          <p:cNvSpPr txBox="1"/>
-          <p:nvPr/>
-        </p:nvSpPr>
-        <p:spPr>
-          <a:xfrm>
-            <a:off x="2932115" y="4434840"/>
-            <a:ext cx="1779971" cy="566928"/>
-          </a:xfrm>
-          <a:prstGeom prst="rect">
-            <a:avLst/>
-          </a:prstGeom>
-          <a:noFill/>
-          <a:ln/>
-        </p:spPr>
-        <p:txBody>
-          <a:bodyPr wrap="square" lIns="0" tIns="0" rIns="0" bIns="0" rtlCol="0" anchor="ctr"/>
-          <a:lstStyle/>
-          <a:p>
-            <a:pPr algn="ctr" indent="0" marL="0">
-              <a:buNone/>
-            </a:pPr>
-            <a:r>
-              <a:rPr lang="en-US" sz="1150" b="1" dirty="0">
-                <a:solidFill>
-                  <a:srgbClr val="14232B"/>
-                </a:solidFill>
-                <a:latin typeface="Arial" pitchFamily="34" charset="0"/>
-                <a:ea typeface="Arial" pitchFamily="34" charset="-122"/>
-                <a:cs typeface="Arial" pitchFamily="34" charset="-120"/>
-              </a:rPr>
-              <a:t>Approved answers and a few questions</a:t>
-            </a:r>
-            <a:endParaRPr lang="en-US" sz="1150" dirty="0"/>
-          </a:p>
-        </p:txBody>
-      </p:sp>
-      <p:sp>
-        <p:nvSpPr>
-          <p:cNvPr id="36" name="Shape 30"/>
-          <p:cNvSpPr/>
-          <p:nvPr/>
-        </p:nvSpPr>
-        <p:spPr>
-          <a:xfrm>
-            <a:off x="4858390" y="4718304"/>
-            <a:ext cx="201168" cy="0"/>
-          </a:xfrm>
-          <a:prstGeom prst="line">
-            <a:avLst/>
-          </a:prstGeom>
-          <a:noFill/>
-          <a:ln w="19050">
-            <a:solidFill>
-              <a:srgbClr val="0E7C6B"/>
-            </a:solidFill>
-            <a:prstDash val="solid"/>
-            <a:tailEnd type="triangle"/>
-          </a:ln>
-        </p:spPr>
-      </p:sp>
-      <p:sp>
-        <p:nvSpPr>
-          <p:cNvPr id="37" name="Shape 31"/>
-          <p:cNvSpPr/>
-          <p:nvPr/>
-        </p:nvSpPr>
-        <p:spPr>
-          <a:xfrm>
-            <a:off x="5096134" y="4434840"/>
-            <a:ext cx="1999427" cy="566928"/>
-          </a:xfrm>
-          <a:prstGeom prst="roundRect">
-            <a:avLst>
-              <a:gd name="adj" fmla="val 19355"/>
-            </a:avLst>
-          </a:prstGeom>
-          <a:solidFill>
-            <a:srgbClr val="FFFFFF"/>
-          </a:solidFill>
-          <a:ln w="9525">
-            <a:solidFill>
-              <a:srgbClr val="D5DEDB"/>
-            </a:solidFill>
-            <a:prstDash val="solid"/>
-          </a:ln>
-        </p:spPr>
-      </p:sp>
-      <p:sp>
-        <p:nvSpPr>
-          <p:cNvPr id="38" name="Text 32"/>
-          <p:cNvSpPr txBox="1"/>
-          <p:nvPr/>
-        </p:nvSpPr>
-        <p:spPr>
-          <a:xfrm>
-            <a:off x="5205862" y="4434840"/>
-            <a:ext cx="1779971" cy="566928"/>
-          </a:xfrm>
-          <a:prstGeom prst="rect">
-            <a:avLst/>
-          </a:prstGeom>
-          <a:noFill/>
-          <a:ln/>
-        </p:spPr>
-        <p:txBody>
-          <a:bodyPr wrap="square" lIns="0" tIns="0" rIns="0" bIns="0" rtlCol="0" anchor="ctr"/>
-          <a:lstStyle/>
-          <a:p>
-            <a:pPr algn="ctr" indent="0" marL="0">
-              <a:buNone/>
-            </a:pPr>
-            <a:r>
-              <a:rPr lang="en-US" sz="1150" b="1" dirty="0">
-                <a:solidFill>
-                  <a:srgbClr val="14232B"/>
-                </a:solidFill>
-                <a:latin typeface="Arial" pitchFamily="34" charset="0"/>
-                <a:ea typeface="Arial" pitchFamily="34" charset="-122"/>
-                <a:cs typeface="Arial" pitchFamily="34" charset="-120"/>
-              </a:rPr>
-              <a:t>Follow-ups if not booked</a:t>
-            </a:r>
-            <a:endParaRPr lang="en-US" sz="1150" dirty="0"/>
-          </a:p>
-        </p:txBody>
-      </p:sp>
-      <p:sp>
-        <p:nvSpPr>
-          <p:cNvPr id="39" name="Shape 33"/>
-          <p:cNvSpPr/>
-          <p:nvPr/>
-        </p:nvSpPr>
-        <p:spPr>
-          <a:xfrm>
-            <a:off x="7132137" y="4718304"/>
-            <a:ext cx="201168" cy="0"/>
-          </a:xfrm>
-          <a:prstGeom prst="line">
-            <a:avLst/>
-          </a:prstGeom>
-          <a:noFill/>
-          <a:ln w="19050">
-            <a:solidFill>
-              <a:srgbClr val="0E7C6B"/>
-            </a:solidFill>
-            <a:prstDash val="solid"/>
-            <a:tailEnd type="triangle"/>
-          </a:ln>
-        </p:spPr>
-      </p:sp>
-      <p:sp>
-        <p:nvSpPr>
-          <p:cNvPr id="40" name="Shape 34"/>
-          <p:cNvSpPr/>
-          <p:nvPr/>
-        </p:nvSpPr>
-        <p:spPr>
-          <a:xfrm>
-            <a:off x="7369881" y="4434840"/>
-            <a:ext cx="1999427" cy="566928"/>
-          </a:xfrm>
-          <a:prstGeom prst="roundRect">
-            <a:avLst>
-              <a:gd name="adj" fmla="val 19355"/>
-            </a:avLst>
-          </a:prstGeom>
-          <a:solidFill>
-            <a:srgbClr val="FFFFFF"/>
-          </a:solidFill>
-          <a:ln w="9525">
-            <a:solidFill>
-              <a:srgbClr val="D5DEDB"/>
-            </a:solidFill>
-            <a:prstDash val="solid"/>
-          </a:ln>
-        </p:spPr>
-      </p:sp>
-      <p:sp>
-        <p:nvSpPr>
-          <p:cNvPr id="41" name="Text 35"/>
-          <p:cNvSpPr txBox="1"/>
-          <p:nvPr/>
-        </p:nvSpPr>
-        <p:spPr>
-          <a:xfrm>
-            <a:off x="7479609" y="4434840"/>
-            <a:ext cx="1779971" cy="566928"/>
-          </a:xfrm>
-          <a:prstGeom prst="rect">
-            <a:avLst/>
-          </a:prstGeom>
-          <a:noFill/>
-          <a:ln/>
-        </p:spPr>
-        <p:txBody>
-          <a:bodyPr wrap="square" lIns="0" tIns="0" rIns="0" bIns="0" rtlCol="0" anchor="ctr"/>
-          <a:lstStyle/>
-          <a:p>
-            <a:pPr algn="ctr" indent="0" marL="0">
-              <a:buNone/>
-            </a:pPr>
-            <a:r>
-              <a:rPr lang="en-US" sz="1150" b="1" dirty="0">
-                <a:solidFill>
-                  <a:srgbClr val="14232B"/>
-                </a:solidFill>
-                <a:latin typeface="Arial" pitchFamily="34" charset="0"/>
-                <a:ea typeface="Arial" pitchFamily="34" charset="-122"/>
-                <a:cs typeface="Arial" pitchFamily="34" charset="-120"/>
-              </a:rPr>
-              <a:t>Booking link or staff call</a:t>
-            </a:r>
-            <a:endParaRPr lang="en-US" sz="1150" dirty="0"/>
-          </a:p>
-        </p:txBody>
-      </p:sp>
-      <p:sp>
-        <p:nvSpPr>
-          <p:cNvPr id="42" name="Shape 36"/>
-          <p:cNvSpPr/>
-          <p:nvPr/>
-        </p:nvSpPr>
-        <p:spPr>
-          <a:xfrm>
-            <a:off x="9405884" y="4718304"/>
-            <a:ext cx="201168" cy="0"/>
-          </a:xfrm>
-          <a:prstGeom prst="line">
-            <a:avLst/>
-          </a:prstGeom>
-          <a:noFill/>
-          <a:ln w="19050">
-            <a:solidFill>
-              <a:srgbClr val="0E7C6B"/>
-            </a:solidFill>
-            <a:prstDash val="solid"/>
-            <a:tailEnd type="triangle"/>
-          </a:ln>
-        </p:spPr>
-      </p:sp>
-      <p:sp>
-        <p:nvSpPr>
-          <p:cNvPr id="43" name="Shape 37"/>
-          <p:cNvSpPr/>
-          <p:nvPr/>
-        </p:nvSpPr>
-        <p:spPr>
-          <a:xfrm>
-            <a:off x="9643628" y="4434840"/>
-            <a:ext cx="1999427" cy="566928"/>
-          </a:xfrm>
-          <a:prstGeom prst="roundRect">
-            <a:avLst>
-              <a:gd name="adj" fmla="val 19355"/>
-            </a:avLst>
-          </a:prstGeom>
-          <a:solidFill>
-            <a:srgbClr val="14232B"/>
-          </a:solidFill>
-          <a:ln w="9525">
-            <a:solidFill>
-              <a:srgbClr val="14232B"/>
-            </a:solidFill>
-            <a:prstDash val="solid"/>
-          </a:ln>
-        </p:spPr>
-      </p:sp>
-      <p:sp>
-        <p:nvSpPr>
-          <p:cNvPr id="44" name="Text 38"/>
-          <p:cNvSpPr txBox="1"/>
-          <p:nvPr/>
-        </p:nvSpPr>
-        <p:spPr>
-          <a:xfrm>
-            <a:off x="9753356" y="4434840"/>
-            <a:ext cx="1779971" cy="566928"/>
-          </a:xfrm>
-          <a:prstGeom prst="rect">
-            <a:avLst/>
-          </a:prstGeom>
-          <a:noFill/>
-          <a:ln/>
-        </p:spPr>
-        <p:txBody>
-          <a:bodyPr wrap="square" lIns="0" tIns="0" rIns="0" bIns="0" rtlCol="0" anchor="ctr"/>
-          <a:lstStyle/>
-          <a:p>
-            <a:pPr algn="ctr" indent="0" marL="0">
-              <a:buNone/>
-            </a:pPr>
-            <a:r>
-              <a:rPr lang="en-US" sz="1150" b="1" dirty="0">
-                <a:solidFill>
-                  <a:srgbClr val="FFFFFF"/>
-                </a:solidFill>
-                <a:latin typeface="Arial" pitchFamily="34" charset="0"/>
-                <a:ea typeface="Arial" pitchFamily="34" charset="-122"/>
-                <a:cs typeface="Arial" pitchFamily="34" charset="-120"/>
-              </a:rPr>
-              <a:t>Status tracked for every enquiry</a:t>
-            </a:r>
-            <a:endParaRPr lang="en-US" sz="1150" dirty="0"/>
-          </a:p>
-        </p:txBody>
-      </p:sp>
-      <p:sp>
-        <p:nvSpPr>
-          <p:cNvPr id="45" name="Text 39"/>
-          <p:cNvSpPr txBox="1"/>
-          <p:nvPr/>
-        </p:nvSpPr>
-        <p:spPr>
-          <a:xfrm>
-            <a:off x="548640" y="5230368"/>
-            <a:ext cx="5486400" cy="237744"/>
-          </a:xfrm>
-          <a:prstGeom prst="rect">
-            <a:avLst/>
-          </a:prstGeom>
-          <a:noFill/>
-          <a:ln/>
-        </p:spPr>
-        <p:txBody>
-          <a:bodyPr wrap="square" lIns="0" tIns="0" rIns="0" bIns="0" rtlCol="0" anchor="t"/>
-          <a:lstStyle/>
-          <a:p>
-            <a:pPr indent="0" marL="0">
-              <a:buNone/>
-            </a:pPr>
-            <a:r>
-              <a:rPr lang="en-US" sz="1050" b="1" spc="150" kern="0" dirty="0">
-                <a:solidFill>
-                  <a:srgbClr val="0E7C6B"/>
-                </a:solidFill>
-                <a:latin typeface="Arial" pitchFamily="34" charset="0"/>
-                <a:ea typeface="Arial" pitchFamily="34" charset="-122"/>
-                <a:cs typeface="Arial" pitchFamily="34" charset="-120"/>
-              </a:rPr>
-              <a:t>WHAT CHANGES FOR THE CLINIC</a:t>
-            </a:r>
-            <a:endParaRPr lang="en-US" sz="1050" dirty="0"/>
-          </a:p>
-        </p:txBody>
-      </p:sp>
-      <p:sp>
-        <p:nvSpPr>
-          <p:cNvPr id="46" name="Shape 40"/>
-          <p:cNvSpPr/>
-          <p:nvPr/>
-        </p:nvSpPr>
-        <p:spPr>
-          <a:xfrm>
-            <a:off x="548640" y="5504688"/>
-            <a:ext cx="2636444" cy="640080"/>
-          </a:xfrm>
-          <a:prstGeom prst="roundRect">
-            <a:avLst>
-              <a:gd name="adj" fmla="val 17143"/>
-            </a:avLst>
-          </a:prstGeom>
-          <a:solidFill>
-            <a:srgbClr val="DCEFEA"/>
-          </a:solidFill>
-          <a:ln/>
-        </p:spPr>
-      </p:sp>
-      <p:pic>
-        <p:nvPicPr>
-          <p:cNvPr id="47" name="Image 4" descr="preencoded.png">    </p:cNvPr>
-          <p:cNvPicPr>
-            <a:picLocks noChangeAspect="1"/>
-          </p:cNvPicPr>
-          <p:nvPr/>
-        </p:nvPicPr>
-        <p:blipFill>
-          <a:blip r:embed="rId5"/>
-          <a:stretch>
-            <a:fillRect/>
-          </a:stretch>
-        </p:blipFill>
-        <p:spPr>
-          <a:xfrm>
-            <a:off x="731520" y="5669280"/>
-            <a:ext cx="310896" cy="310896"/>
-          </a:xfrm>
-          <a:prstGeom prst="rect">
-            <a:avLst/>
-          </a:prstGeom>
-        </p:spPr>
-      </p:pic>
-      <p:sp>
-        <p:nvSpPr>
-          <p:cNvPr id="48" name="Text 41"/>
-          <p:cNvSpPr txBox="1"/>
-          <p:nvPr/>
-        </p:nvSpPr>
-        <p:spPr>
-          <a:xfrm>
-            <a:off x="1170432" y="5504688"/>
-            <a:ext cx="1859204" cy="640080"/>
-          </a:xfrm>
-          <a:prstGeom prst="rect">
-            <a:avLst/>
-          </a:prstGeom>
-          <a:noFill/>
-          <a:ln/>
-        </p:spPr>
-        <p:txBody>
-          <a:bodyPr wrap="square" lIns="0" tIns="0" rIns="0" bIns="0" rtlCol="0" anchor="ctr"/>
-          <a:lstStyle/>
-          <a:p>
-            <a:pPr indent="0" marL="0">
-              <a:buNone/>
-            </a:pPr>
-            <a:r>
-              <a:rPr lang="en-US" sz="1200" b="1" dirty="0">
-                <a:solidFill>
-                  <a:srgbClr val="14232B"/>
-                </a:solidFill>
-                <a:latin typeface="Arial" pitchFamily="34" charset="0"/>
-                <a:ea typeface="Arial" pitchFamily="34" charset="-122"/>
-                <a:cs typeface="Arial" pitchFamily="34" charset="-120"/>
-              </a:rPr>
-              <a:t>No enquiry goes unanswered</a:t>
-            </a:r>
-            <a:endParaRPr lang="en-US" sz="1200" dirty="0"/>
-          </a:p>
-        </p:txBody>
-      </p:sp>
-      <p:sp>
-        <p:nvSpPr>
-          <p:cNvPr id="49" name="Shape 42"/>
-          <p:cNvSpPr/>
-          <p:nvPr/>
-        </p:nvSpPr>
-        <p:spPr>
-          <a:xfrm>
-            <a:off x="3367964" y="5504688"/>
-            <a:ext cx="2636444" cy="640080"/>
-          </a:xfrm>
-          <a:prstGeom prst="roundRect">
-            <a:avLst>
-              <a:gd name="adj" fmla="val 17143"/>
-            </a:avLst>
-          </a:prstGeom>
-          <a:solidFill>
-            <a:srgbClr val="DCEFEA"/>
-          </a:solidFill>
-          <a:ln/>
-        </p:spPr>
-      </p:sp>
-      <p:pic>
-        <p:nvPicPr>
-          <p:cNvPr id="50" name="Image 5" descr="preencoded.png">    </p:cNvPr>
-          <p:cNvPicPr>
-            <a:picLocks noChangeAspect="1"/>
-          </p:cNvPicPr>
-          <p:nvPr/>
-        </p:nvPicPr>
-        <p:blipFill>
-          <a:blip r:embed="rId6"/>
-          <a:stretch>
-            <a:fillRect/>
-          </a:stretch>
-        </p:blipFill>
-        <p:spPr>
-          <a:xfrm>
-            <a:off x="3550844" y="5669280"/>
-            <a:ext cx="310896" cy="310896"/>
-          </a:xfrm>
-          <a:prstGeom prst="rect">
-            <a:avLst/>
-          </a:prstGeom>
-        </p:spPr>
-      </p:pic>
-      <p:sp>
-        <p:nvSpPr>
-          <p:cNvPr id="51" name="Text 43"/>
-          <p:cNvSpPr txBox="1"/>
-          <p:nvPr/>
-        </p:nvSpPr>
-        <p:spPr>
-          <a:xfrm>
-            <a:off x="3989756" y="5504688"/>
-            <a:ext cx="1859204" cy="640080"/>
-          </a:xfrm>
-          <a:prstGeom prst="rect">
-            <a:avLst/>
-          </a:prstGeom>
-          <a:noFill/>
-          <a:ln/>
-        </p:spPr>
-        <p:txBody>
-          <a:bodyPr wrap="square" lIns="0" tIns="0" rIns="0" bIns="0" rtlCol="0" anchor="ctr"/>
-          <a:lstStyle/>
-          <a:p>
-            <a:pPr indent="0" marL="0">
-              <a:buNone/>
-            </a:pPr>
-            <a:r>
-              <a:rPr lang="en-US" sz="1200" b="1" dirty="0">
-                <a:solidFill>
-                  <a:srgbClr val="14232B"/>
-                </a:solidFill>
-                <a:latin typeface="Arial" pitchFamily="34" charset="0"/>
-                <a:ea typeface="Arial" pitchFamily="34" charset="-122"/>
-                <a:cs typeface="Arial" pitchFamily="34" charset="-120"/>
-              </a:rPr>
-              <a:t>Follow-up happens without staff chasing</a:t>
-            </a:r>
-            <a:endParaRPr lang="en-US" sz="1200" dirty="0"/>
-          </a:p>
-        </p:txBody>
-      </p:sp>
-      <p:sp>
-        <p:nvSpPr>
-          <p:cNvPr id="52" name="Shape 44"/>
-          <p:cNvSpPr/>
-          <p:nvPr/>
-        </p:nvSpPr>
-        <p:spPr>
-          <a:xfrm>
-            <a:off x="6187288" y="5504688"/>
-            <a:ext cx="2636444" cy="640080"/>
-          </a:xfrm>
-          <a:prstGeom prst="roundRect">
-            <a:avLst>
-              <a:gd name="adj" fmla="val 17143"/>
-            </a:avLst>
-          </a:prstGeom>
-          <a:solidFill>
-            <a:srgbClr val="DCEFEA"/>
-          </a:solidFill>
-          <a:ln/>
-        </p:spPr>
-      </p:sp>
-      <p:pic>
-        <p:nvPicPr>
-          <p:cNvPr id="53" name="Image 6" descr="preencoded.png">    </p:cNvPr>
-          <p:cNvPicPr>
-            <a:picLocks noChangeAspect="1"/>
-          </p:cNvPicPr>
-          <p:nvPr/>
-        </p:nvPicPr>
-        <p:blipFill>
-          <a:blip r:embed="rId7"/>
-          <a:stretch>
-            <a:fillRect/>
-          </a:stretch>
-        </p:blipFill>
-        <p:spPr>
-          <a:xfrm>
-            <a:off x="6370168" y="5669280"/>
-            <a:ext cx="310896" cy="310896"/>
-          </a:xfrm>
-          <a:prstGeom prst="rect">
-            <a:avLst/>
-          </a:prstGeom>
-        </p:spPr>
-      </p:pic>
-      <p:sp>
-        <p:nvSpPr>
-          <p:cNvPr id="54" name="Text 45"/>
-          <p:cNvSpPr txBox="1"/>
-          <p:nvPr/>
-        </p:nvSpPr>
-        <p:spPr>
-          <a:xfrm>
-            <a:off x="6809080" y="5504688"/>
-            <a:ext cx="1859204" cy="640080"/>
-          </a:xfrm>
-          <a:prstGeom prst="rect">
-            <a:avLst/>
-          </a:prstGeom>
-          <a:noFill/>
-          <a:ln/>
-        </p:spPr>
-        <p:txBody>
-          <a:bodyPr wrap="square" lIns="0" tIns="0" rIns="0" bIns="0" rtlCol="0" anchor="ctr"/>
-          <a:lstStyle/>
-          <a:p>
-            <a:pPr indent="0" marL="0">
-              <a:buNone/>
-            </a:pPr>
-            <a:r>
-              <a:rPr lang="en-US" sz="1200" b="1" dirty="0">
-                <a:solidFill>
-                  <a:srgbClr val="14232B"/>
-                </a:solidFill>
-                <a:latin typeface="Arial" pitchFamily="34" charset="0"/>
-                <a:ea typeface="Arial" pitchFamily="34" charset="-122"/>
-                <a:cs typeface="Arial" pitchFamily="34" charset="-120"/>
-              </a:rPr>
-              <a:t>Fewer missed bookings left unrecovered</a:t>
-            </a:r>
-            <a:endParaRPr lang="en-US" sz="1200" dirty="0"/>
-          </a:p>
-        </p:txBody>
-      </p:sp>
-      <p:sp>
-        <p:nvSpPr>
-          <p:cNvPr id="55" name="Shape 46"/>
-          <p:cNvSpPr/>
-          <p:nvPr/>
-        </p:nvSpPr>
-        <p:spPr>
-          <a:xfrm>
-            <a:off x="9006611" y="5504688"/>
-            <a:ext cx="2636444" cy="640080"/>
-          </a:xfrm>
-          <a:prstGeom prst="roundRect">
-            <a:avLst>
-              <a:gd name="adj" fmla="val 17143"/>
-            </a:avLst>
-          </a:prstGeom>
-          <a:solidFill>
-            <a:srgbClr val="DCEFEA"/>
-          </a:solidFill>
-          <a:ln/>
-        </p:spPr>
-      </p:sp>
-      <p:pic>
-        <p:nvPicPr>
-          <p:cNvPr id="56" name="Image 7" descr="preencoded.png">    </p:cNvPr>
-          <p:cNvPicPr>
-            <a:picLocks noChangeAspect="1"/>
-          </p:cNvPicPr>
-          <p:nvPr/>
-        </p:nvPicPr>
-        <p:blipFill>
-          <a:blip r:embed="rId8"/>
-          <a:stretch>
-            <a:fillRect/>
-          </a:stretch>
-        </p:blipFill>
-        <p:spPr>
-          <a:xfrm>
-            <a:off x="9189491" y="5669280"/>
-            <a:ext cx="310896" cy="310896"/>
-          </a:xfrm>
-          <a:prstGeom prst="rect">
-            <a:avLst/>
-          </a:prstGeom>
-        </p:spPr>
-      </p:pic>
-      <p:sp>
-        <p:nvSpPr>
-          <p:cNvPr id="57" name="Text 47"/>
-          <p:cNvSpPr txBox="1"/>
-          <p:nvPr/>
-        </p:nvSpPr>
-        <p:spPr>
-          <a:xfrm>
-            <a:off x="9628403" y="5504688"/>
-            <a:ext cx="1859204" cy="640080"/>
-          </a:xfrm>
-          <a:prstGeom prst="rect">
-            <a:avLst/>
-          </a:prstGeom>
-          <a:noFill/>
-          <a:ln/>
-        </p:spPr>
-        <p:txBody>
-          <a:bodyPr wrap="square" lIns="0" tIns="0" rIns="0" bIns="0" rtlCol="0" anchor="ctr"/>
-          <a:lstStyle/>
-          <a:p>
-            <a:pPr indent="0" marL="0">
-              <a:buNone/>
-            </a:pPr>
-            <a:r>
-              <a:rPr lang="en-US" sz="1200" b="1" dirty="0">
-                <a:solidFill>
-                  <a:srgbClr val="14232B"/>
-                </a:solidFill>
-                <a:latin typeface="Arial" pitchFamily="34" charset="0"/>
-                <a:ea typeface="Arial" pitchFamily="34" charset="-122"/>
-                <a:cs typeface="Arial" pitchFamily="34" charset="-120"/>
-              </a:rPr>
-              <a:t>A clear view of every patient's status</a:t>
+              <a:rPr lang="en-US" sz="1200" dirty="0">
+                <a:solidFill>
+                  <a:srgbClr val="C9D6D3"/>
+                </a:solidFill>
+                <a:latin typeface="Arial" pitchFamily="34" charset="0"/>
+                <a:ea typeface="Arial" pitchFamily="34" charset="-122"/>
+                <a:cs typeface="Arial" pitchFamily="34" charset="-120"/>
+              </a:rPr>
+              <a:t>Prepared by Patientcurve  ·  patientcurve.com</a:t>
             </a:r>
             <a:endParaRPr lang="en-US" sz="1200" dirty="0"/>
           </a:p>
@@ -2993,7 +1623,7 @@
                 <a:ea typeface="Arial" pitchFamily="34" charset="-122"/>
                 <a:cs typeface="Arial" pitchFamily="34" charset="-120"/>
               </a:rPr>
-              <a:t>PROPOSAL FOR DR. AISHWARYA ARUN  ·  PRICING AND NEXT STEPS</a:t>
+              <a:t>PROPOSAL FOR DR. AISHWARYA ARUN  ·  THE PROBLEM AND THE SOLUTION</a:t>
             </a:r>
             <a:endParaRPr lang="en-US" sz="1100" dirty="0"/>
           </a:p>
@@ -3032,7 +1662,7 @@
                 <a:ea typeface="Arial" pitchFamily="34" charset="-122"/>
                 <a:cs typeface="Arial" pitchFamily="34" charset="-120"/>
               </a:rPr>
-              <a:t>Your pilot price and clear scope</a:t>
+              <a:t>Every enquiry deserves a next step</a:t>
             </a:r>
             <a:endParaRPr lang="en-US" sz="2800" dirty="0"/>
           </a:p>
@@ -3114,15 +1744,1987 @@
               <a:buNone/>
             </a:pPr>
             <a:r>
+              <a:rPr lang="en-US" sz="1000" dirty="0">
+                <a:solidFill>
+                  <a:srgbClr val="5B6B70"/>
+                </a:solidFill>
+                <a:latin typeface="Arial" pitchFamily="34" charset="0"/>
+                <a:ea typeface="Arial" pitchFamily="34" charset="-122"/>
+                <a:cs typeface="Arial" pitchFamily="34" charset="-120"/>
+              </a:rPr>
+              <a:t>Kannan Prime Dental</a:t>
+            </a:r>
+            <a:pPr indent="0" marL="0">
+              <a:buNone/>
+            </a:pPr>
+            <a:r>
+              <a:rPr lang="en-US" sz="1000" dirty="0">
+                <a:solidFill>
+                  <a:srgbClr val="5B6B70"/>
+                </a:solidFill>
+                <a:latin typeface="Arial" pitchFamily="34" charset="0"/>
+                <a:ea typeface="Arial" pitchFamily="34" charset="-122"/>
+                <a:cs typeface="Arial" pitchFamily="34" charset="-120"/>
+              </a:rPr>
+              <a:t>  ·  10 Oct 2026</a:t>
+            </a:r>
+            <a:endParaRPr lang="en-US" sz="1000" dirty="0"/>
+          </a:p>
+        </p:txBody>
+      </p:sp>
+      <p:sp>
+        <p:nvSpPr>
+          <p:cNvPr id="7" name="Text 4"/>
+          <p:cNvSpPr txBox="1"/>
+          <p:nvPr/>
+        </p:nvSpPr>
+        <p:spPr>
+          <a:xfrm>
+            <a:off x="8412480" y="6437376"/>
+            <a:ext cx="3230575" cy="237744"/>
+          </a:xfrm>
+          <a:prstGeom prst="rect">
+            <a:avLst/>
+          </a:prstGeom>
+          <a:noFill/>
+          <a:ln/>
+        </p:spPr>
+        <p:txBody>
+          <a:bodyPr wrap="square" lIns="0" tIns="0" rIns="0" bIns="0" rtlCol="0" anchor="ctr"/>
+          <a:lstStyle/>
+          <a:p>
+            <a:pPr algn="r" indent="0" marL="0">
+              <a:buNone/>
+            </a:pPr>
+            <a:r>
+              <a:rPr lang="en-US" sz="1000" dirty="0">
+                <a:solidFill>
+                  <a:srgbClr val="5B6B70"/>
+                </a:solidFill>
+                <a:latin typeface="Arial" pitchFamily="34" charset="0"/>
+                <a:ea typeface="Arial" pitchFamily="34" charset="-122"/>
+                <a:cs typeface="Arial" pitchFamily="34" charset="-120"/>
+              </a:rPr>
+              <a:t>Patientcurve proposal  ·  1 / 2</a:t>
+            </a:r>
+            <a:endParaRPr lang="en-US" sz="1000" dirty="0"/>
+          </a:p>
+        </p:txBody>
+      </p:sp>
+      <p:sp>
+        <p:nvSpPr>
+          <p:cNvPr id="8" name="Text 5"/>
+          <p:cNvSpPr txBox="1"/>
+          <p:nvPr/>
+        </p:nvSpPr>
+        <p:spPr>
+          <a:xfrm>
+            <a:off x="7223760" y="786384"/>
+            <a:ext cx="4419295" cy="475488"/>
+          </a:xfrm>
+          <a:prstGeom prst="rect">
+            <a:avLst/>
+          </a:prstGeom>
+          <a:noFill/>
+          <a:ln/>
+        </p:spPr>
+        <p:txBody>
+          <a:bodyPr wrap="square" lIns="0" tIns="0" rIns="0" bIns="0" rtlCol="0" anchor="t"/>
+          <a:lstStyle/>
+          <a:p>
+            <a:pPr algn="r" indent="0" marL="0">
+              <a:buNone/>
+            </a:pPr>
+            <a:r>
+              <a:rPr lang="en-US" sz="1250" dirty="0">
+                <a:solidFill>
+                  <a:srgbClr val="5B6B70"/>
+                </a:solidFill>
+                <a:latin typeface="Arial" pitchFamily="34" charset="0"/>
+                <a:ea typeface="Arial" pitchFamily="34" charset="-122"/>
+                <a:cs typeface="Arial" pitchFamily="34" charset="-120"/>
+              </a:rPr>
+              <a:t>Prepared for </a:t>
+            </a:r>
+            <a:pPr algn="r" indent="0" marL="0">
+              <a:buNone/>
+            </a:pPr>
+            <a:r>
+              <a:rPr lang="en-US" sz="1250" b="1" dirty="0">
+                <a:solidFill>
+                  <a:srgbClr val="14232B"/>
+                </a:solidFill>
+                <a:latin typeface="Arial" pitchFamily="34" charset="0"/>
+                <a:ea typeface="Arial" pitchFamily="34" charset="-122"/>
+                <a:cs typeface="Arial" pitchFamily="34" charset="-120"/>
+              </a:rPr>
+              <a:t>Dr. Aishwarya Arun</a:t>
+            </a:r>
+            <a:endParaRPr lang="en-US" sz="1250" dirty="0"/>
+          </a:p>
+          <a:p>
+            <a:pPr algn="r" indent="0" marL="0">
+              <a:buNone/>
+            </a:pPr>
+            <a:r>
+              <a:rPr lang="en-US" sz="1250" b="1" dirty="0">
+                <a:solidFill>
+                  <a:srgbClr val="14232B"/>
+                </a:solidFill>
+                <a:latin typeface="Arial" pitchFamily="34" charset="0"/>
+                <a:ea typeface="Arial" pitchFamily="34" charset="-122"/>
+                <a:cs typeface="Arial" pitchFamily="34" charset="-120"/>
+              </a:rPr>
+              <a:t>Kannan Prime Dental</a:t>
+            </a:r>
+            <a:pPr algn="r" indent="0" marL="0">
+              <a:buNone/>
+            </a:pPr>
+            <a:r>
+              <a:rPr lang="en-US" sz="1250" dirty="0">
+                <a:solidFill>
+                  <a:srgbClr val="5B6B70"/>
+                </a:solidFill>
+                <a:latin typeface="Arial" pitchFamily="34" charset="0"/>
+                <a:ea typeface="Arial" pitchFamily="34" charset="-122"/>
+                <a:cs typeface="Arial" pitchFamily="34" charset="-120"/>
+              </a:rPr>
+              <a:t>   ·   10 Oct 2026</a:t>
+            </a:r>
+            <a:endParaRPr lang="en-US" sz="1250" dirty="0"/>
+          </a:p>
+        </p:txBody>
+      </p:sp>
+      <p:sp>
+        <p:nvSpPr>
+          <p:cNvPr id="9" name="Shape 6"/>
+          <p:cNvSpPr/>
+          <p:nvPr/>
+        </p:nvSpPr>
+        <p:spPr>
+          <a:xfrm>
+            <a:off x="548640" y="1417320"/>
+            <a:ext cx="3611880" cy="2514600"/>
+          </a:xfrm>
+          <a:prstGeom prst="roundRect">
+            <a:avLst>
+              <a:gd name="adj" fmla="val 4364"/>
+            </a:avLst>
+          </a:prstGeom>
+          <a:solidFill>
+            <a:srgbClr val="14232B"/>
+          </a:solidFill>
+          <a:ln/>
+        </p:spPr>
+      </p:sp>
+      <p:sp>
+        <p:nvSpPr>
+          <p:cNvPr id="10" name="Text 7"/>
+          <p:cNvSpPr txBox="1"/>
+          <p:nvPr/>
+        </p:nvSpPr>
+        <p:spPr>
+          <a:xfrm>
+            <a:off x="822960" y="1645920"/>
+            <a:ext cx="3108960" cy="237744"/>
+          </a:xfrm>
+          <a:prstGeom prst="rect">
+            <a:avLst/>
+          </a:prstGeom>
+          <a:noFill/>
+          <a:ln/>
+        </p:spPr>
+        <p:txBody>
+          <a:bodyPr wrap="square" lIns="0" tIns="0" rIns="0" bIns="0" rtlCol="0" anchor="t"/>
+          <a:lstStyle/>
+          <a:p>
+            <a:pPr indent="0" marL="0">
+              <a:buNone/>
+            </a:pPr>
+            <a:r>
+              <a:rPr lang="en-US" sz="1050" b="1" spc="150" kern="0" dirty="0">
+                <a:solidFill>
+                  <a:srgbClr val="3FC0A6"/>
+                </a:solidFill>
+                <a:latin typeface="Arial" pitchFamily="34" charset="0"/>
+                <a:ea typeface="Arial" pitchFamily="34" charset="-122"/>
+                <a:cs typeface="Arial" pitchFamily="34" charset="-120"/>
+              </a:rPr>
+              <a:t>THE PROBLEM</a:t>
+            </a:r>
+            <a:endParaRPr lang="en-US" sz="1050" dirty="0"/>
+          </a:p>
+        </p:txBody>
+      </p:sp>
+      <p:sp>
+        <p:nvSpPr>
+          <p:cNvPr id="11" name="Text 8"/>
+          <p:cNvSpPr txBox="1"/>
+          <p:nvPr/>
+        </p:nvSpPr>
+        <p:spPr>
+          <a:xfrm>
+            <a:off x="822960" y="1938528"/>
+            <a:ext cx="3108960" cy="594360"/>
+          </a:xfrm>
+          <a:prstGeom prst="rect">
+            <a:avLst/>
+          </a:prstGeom>
+          <a:noFill/>
+          <a:ln/>
+        </p:spPr>
+        <p:txBody>
+          <a:bodyPr wrap="square" lIns="0" tIns="0" rIns="0" bIns="0" rtlCol="0" anchor="t"/>
+          <a:lstStyle/>
+          <a:p>
+            <a:pPr indent="0" marL="0">
+              <a:buNone/>
+            </a:pPr>
+            <a:r>
+              <a:rPr lang="en-US" sz="1450" b="1" dirty="0">
+                <a:solidFill>
+                  <a:srgbClr val="FFFFFF"/>
+                </a:solidFill>
+                <a:latin typeface="Arial" pitchFamily="34" charset="0"/>
+                <a:ea typeface="Arial" pitchFamily="34" charset="-122"/>
+                <a:cs typeface="Arial" pitchFamily="34" charset="-120"/>
+              </a:rPr>
+              <a:t>Patients don't leave. They slip away between conversations.</a:t>
+            </a:r>
+            <a:endParaRPr lang="en-US" sz="1450" dirty="0"/>
+          </a:p>
+        </p:txBody>
+      </p:sp>
+      <p:sp>
+        <p:nvSpPr>
+          <p:cNvPr id="12" name="Text 9"/>
+          <p:cNvSpPr txBox="1"/>
+          <p:nvPr/>
+        </p:nvSpPr>
+        <p:spPr>
+          <a:xfrm>
+            <a:off x="822960" y="2651760"/>
+            <a:ext cx="3108960" cy="1188720"/>
+          </a:xfrm>
+          <a:prstGeom prst="rect">
+            <a:avLst/>
+          </a:prstGeom>
+          <a:noFill/>
+          <a:ln/>
+        </p:spPr>
+        <p:txBody>
+          <a:bodyPr wrap="square" lIns="0" tIns="0" rIns="0" bIns="0" rtlCol="0" anchor="t"/>
+          <a:lstStyle/>
+          <a:p>
+            <a:pPr marL="190500" indent="-190500">
+              <a:spcAft>
+                <a:spcPts val="400"/>
+              </a:spcAft>
+              <a:buSzPct val="100000"/>
+              <a:buChar char="•"/>
+            </a:pPr>
+            <a:r>
+              <a:rPr lang="en-US" sz="1150" dirty="0">
+                <a:solidFill>
+                  <a:srgbClr val="C9D6D3"/>
+                </a:solidFill>
+                <a:latin typeface="Arial" pitchFamily="34" charset="0"/>
+                <a:ea typeface="Arial" pitchFamily="34" charset="-122"/>
+                <a:cs typeface="Arial" pitchFamily="34" charset="-120"/>
+              </a:rPr>
+              <a:t>Enquiries wait for a reply after hours or on busy days</a:t>
+            </a:r>
+            <a:endParaRPr lang="en-US" sz="1150" dirty="0"/>
+          </a:p>
+          <a:p>
+            <a:pPr marL="190500" indent="-190500">
+              <a:spcAft>
+                <a:spcPts val="400"/>
+              </a:spcAft>
+              <a:buSzPct val="100000"/>
+              <a:buChar char="•"/>
+            </a:pPr>
+            <a:r>
+              <a:rPr lang="en-US" sz="1150" dirty="0">
+                <a:solidFill>
+                  <a:srgbClr val="C9D6D3"/>
+                </a:solidFill>
+                <a:latin typeface="Arial" pitchFamily="34" charset="0"/>
+                <a:ea typeface="Arial" pitchFamily="34" charset="-122"/>
+                <a:cs typeface="Arial" pitchFamily="34" charset="-120"/>
+              </a:rPr>
+              <a:t>Patients who don't book on the first reply never hear back</a:t>
+            </a:r>
+            <a:endParaRPr lang="en-US" sz="1150" dirty="0"/>
+          </a:p>
+          <a:p>
+            <a:pPr marL="190500" indent="-190500">
+              <a:spcAft>
+                <a:spcPts val="400"/>
+              </a:spcAft>
+              <a:buSzPct val="100000"/>
+              <a:buChar char="•"/>
+            </a:pPr>
+            <a:r>
+              <a:rPr lang="en-US" sz="1150" dirty="0">
+                <a:solidFill>
+                  <a:srgbClr val="C9D6D3"/>
+                </a:solidFill>
+                <a:latin typeface="Arial" pitchFamily="34" charset="0"/>
+                <a:ea typeface="Arial" pitchFamily="34" charset="-122"/>
+                <a:cs typeface="Arial" pitchFamily="34" charset="-120"/>
+              </a:rPr>
+              <a:t>Missed visits and recalls depend on someone remembering</a:t>
+            </a:r>
+            <a:endParaRPr lang="en-US" sz="1150" dirty="0"/>
+          </a:p>
+        </p:txBody>
+      </p:sp>
+      <p:sp>
+        <p:nvSpPr>
+          <p:cNvPr id="13" name="Text 10"/>
+          <p:cNvSpPr txBox="1"/>
+          <p:nvPr/>
+        </p:nvSpPr>
+        <p:spPr>
+          <a:xfrm>
+            <a:off x="4389120" y="1417320"/>
+            <a:ext cx="6400800" cy="237744"/>
+          </a:xfrm>
+          <a:prstGeom prst="rect">
+            <a:avLst/>
+          </a:prstGeom>
+          <a:noFill/>
+          <a:ln/>
+        </p:spPr>
+        <p:txBody>
+          <a:bodyPr wrap="square" lIns="0" tIns="0" rIns="0" bIns="0" rtlCol="0" anchor="t"/>
+          <a:lstStyle/>
+          <a:p>
+            <a:pPr indent="0" marL="0">
+              <a:buNone/>
+            </a:pPr>
+            <a:r>
+              <a:rPr lang="en-US" sz="1050" b="1" spc="150" kern="0" dirty="0">
+                <a:solidFill>
+                  <a:srgbClr val="0E7C6B"/>
+                </a:solidFill>
+                <a:latin typeface="Arial" pitchFamily="34" charset="0"/>
+                <a:ea typeface="Arial" pitchFamily="34" charset="-122"/>
+                <a:cs typeface="Arial" pitchFamily="34" charset="-120"/>
+              </a:rPr>
+              <a:t>WHAT PATIENTCURVE DOES</a:t>
+            </a:r>
+            <a:endParaRPr lang="en-US" sz="1050" dirty="0"/>
+          </a:p>
+        </p:txBody>
+      </p:sp>
+      <p:sp>
+        <p:nvSpPr>
+          <p:cNvPr id="14" name="Text 11"/>
+          <p:cNvSpPr txBox="1"/>
+          <p:nvPr/>
+        </p:nvSpPr>
+        <p:spPr>
+          <a:xfrm>
+            <a:off x="4389120" y="1691640"/>
+            <a:ext cx="7253935" cy="274320"/>
+          </a:xfrm>
+          <a:prstGeom prst="rect">
+            <a:avLst/>
+          </a:prstGeom>
+          <a:noFill/>
+          <a:ln/>
+        </p:spPr>
+        <p:txBody>
+          <a:bodyPr wrap="square" lIns="0" tIns="0" rIns="0" bIns="0" rtlCol="0" anchor="t"/>
+          <a:lstStyle/>
+          <a:p>
+            <a:pPr indent="0" marL="0">
+              <a:buNone/>
+            </a:pPr>
+            <a:r>
+              <a:rPr lang="en-US" sz="1250" dirty="0">
+                <a:solidFill>
+                  <a:srgbClr val="5B6B70"/>
+                </a:solidFill>
+                <a:latin typeface="Arial" pitchFamily="34" charset="0"/>
+                <a:ea typeface="Arial" pitchFamily="34" charset="-122"/>
+                <a:cs typeface="Arial" pitchFamily="34" charset="-120"/>
+              </a:rPr>
+              <a:t>Structured WhatsApp follow-ups on the clinic's own number, using clinic-approved messages.</a:t>
+            </a:r>
+            <a:endParaRPr lang="en-US" sz="1250" dirty="0"/>
+          </a:p>
+        </p:txBody>
+      </p:sp>
+      <p:sp>
+        <p:nvSpPr>
+          <p:cNvPr id="15" name="Shape 12"/>
+          <p:cNvSpPr/>
+          <p:nvPr/>
+        </p:nvSpPr>
+        <p:spPr>
+          <a:xfrm>
+            <a:off x="4389120" y="2103120"/>
+            <a:ext cx="2296058" cy="1828800"/>
+          </a:xfrm>
+          <a:prstGeom prst="roundRect">
+            <a:avLst>
+              <a:gd name="adj" fmla="val 6000"/>
+            </a:avLst>
+          </a:prstGeom>
+          <a:solidFill>
+            <a:srgbClr val="FFFFFF"/>
+          </a:solidFill>
+          <a:ln w="9525">
+            <a:solidFill>
+              <a:srgbClr val="D5DEDB"/>
+            </a:solidFill>
+            <a:prstDash val="solid"/>
+          </a:ln>
+        </p:spPr>
+      </p:sp>
+      <p:sp>
+        <p:nvSpPr>
+          <p:cNvPr id="16" name="Text 13"/>
+          <p:cNvSpPr txBox="1"/>
+          <p:nvPr/>
+        </p:nvSpPr>
+        <p:spPr>
+          <a:xfrm>
+            <a:off x="4617720" y="2240280"/>
+            <a:ext cx="457200" cy="411480"/>
+          </a:xfrm>
+          <a:prstGeom prst="rect">
+            <a:avLst/>
+          </a:prstGeom>
+          <a:noFill/>
+          <a:ln/>
+        </p:spPr>
+        <p:txBody>
+          <a:bodyPr wrap="square" lIns="0" tIns="0" rIns="0" bIns="0" rtlCol="0" anchor="t"/>
+          <a:lstStyle/>
+          <a:p>
+            <a:pPr indent="0" marL="0">
+              <a:buNone/>
+            </a:pPr>
+            <a:r>
+              <a:rPr lang="en-US" sz="2200" b="1" dirty="0">
+                <a:solidFill>
+                  <a:srgbClr val="0E7C6B"/>
+                </a:solidFill>
+                <a:latin typeface="Arial" pitchFamily="34" charset="0"/>
+                <a:ea typeface="Arial" pitchFamily="34" charset="-122"/>
+                <a:cs typeface="Arial" pitchFamily="34" charset="-120"/>
+              </a:rPr>
+              <a:t>1</a:t>
+            </a:r>
+            <a:endParaRPr lang="en-US" sz="2200" dirty="0"/>
+          </a:p>
+        </p:txBody>
+      </p:sp>
+      <p:pic>
+        <p:nvPicPr>
+          <p:cNvPr id="17" name="Image 1" descr="preencoded.png">    </p:cNvPr>
+          <p:cNvPicPr>
+            <a:picLocks noChangeAspect="1"/>
+          </p:cNvPicPr>
+          <p:nvPr/>
+        </p:nvPicPr>
+        <p:blipFill>
+          <a:blip r:embed="rId2"/>
+          <a:stretch>
+            <a:fillRect/>
+          </a:stretch>
+        </p:blipFill>
+        <p:spPr>
+          <a:xfrm>
+            <a:off x="6090818" y="2286000"/>
+            <a:ext cx="347472" cy="347472"/>
+          </a:xfrm>
+          <a:prstGeom prst="rect">
+            <a:avLst/>
+          </a:prstGeom>
+        </p:spPr>
+      </p:pic>
+      <p:sp>
+        <p:nvSpPr>
+          <p:cNvPr id="18" name="Text 14"/>
+          <p:cNvSpPr txBox="1"/>
+          <p:nvPr/>
+        </p:nvSpPr>
+        <p:spPr>
+          <a:xfrm>
+            <a:off x="4617720" y="2697480"/>
+            <a:ext cx="1838858" cy="320040"/>
+          </a:xfrm>
+          <a:prstGeom prst="rect">
+            <a:avLst/>
+          </a:prstGeom>
+          <a:noFill/>
+          <a:ln/>
+        </p:spPr>
+        <p:txBody>
+          <a:bodyPr wrap="square" lIns="0" tIns="0" rIns="0" bIns="0" rtlCol="0" anchor="t"/>
+          <a:lstStyle/>
+          <a:p>
+            <a:pPr indent="0" marL="0">
+              <a:buNone/>
+            </a:pPr>
+            <a:r>
+              <a:rPr lang="en-US" sz="1600" b="1" dirty="0">
+                <a:solidFill>
+                  <a:srgbClr val="14232B"/>
+                </a:solidFill>
+                <a:latin typeface="Arial" pitchFamily="34" charset="0"/>
+                <a:ea typeface="Arial" pitchFamily="34" charset="-122"/>
+                <a:cs typeface="Arial" pitchFamily="34" charset="-120"/>
+              </a:rPr>
+              <a:t>Capture</a:t>
+            </a:r>
+            <a:endParaRPr lang="en-US" sz="1600" dirty="0"/>
+          </a:p>
+        </p:txBody>
+      </p:sp>
+      <p:sp>
+        <p:nvSpPr>
+          <p:cNvPr id="19" name="Text 15"/>
+          <p:cNvSpPr txBox="1"/>
+          <p:nvPr/>
+        </p:nvSpPr>
+        <p:spPr>
+          <a:xfrm>
+            <a:off x="4617720" y="3063240"/>
+            <a:ext cx="1884578" cy="777240"/>
+          </a:xfrm>
+          <a:prstGeom prst="rect">
+            <a:avLst/>
+          </a:prstGeom>
+          <a:noFill/>
+          <a:ln/>
+        </p:spPr>
+        <p:txBody>
+          <a:bodyPr wrap="square" lIns="0" tIns="0" rIns="0" bIns="0" rtlCol="0" anchor="t"/>
+          <a:lstStyle/>
+          <a:p>
+            <a:pPr indent="0" marL="0">
+              <a:buNone/>
+            </a:pPr>
+            <a:r>
+              <a:rPr lang="en-US" sz="1150" dirty="0">
+                <a:solidFill>
+                  <a:srgbClr val="5B6B70"/>
+                </a:solidFill>
+                <a:latin typeface="Arial" pitchFamily="34" charset="0"/>
+                <a:ea typeface="Arial" pitchFamily="34" charset="-122"/>
+                <a:cs typeface="Arial" pitchFamily="34" charset="-120"/>
+              </a:rPr>
+              <a:t>Every enquiry is answered and recorded with the patient's need, day or night.</a:t>
+            </a:r>
+            <a:endParaRPr lang="en-US" sz="1150" dirty="0"/>
+          </a:p>
+        </p:txBody>
+      </p:sp>
+      <p:sp>
+        <p:nvSpPr>
+          <p:cNvPr id="20" name="Shape 16"/>
+          <p:cNvSpPr/>
+          <p:nvPr/>
+        </p:nvSpPr>
+        <p:spPr>
+          <a:xfrm>
+            <a:off x="6868058" y="2103120"/>
+            <a:ext cx="2296058" cy="1828800"/>
+          </a:xfrm>
+          <a:prstGeom prst="roundRect">
+            <a:avLst>
+              <a:gd name="adj" fmla="val 6000"/>
+            </a:avLst>
+          </a:prstGeom>
+          <a:solidFill>
+            <a:srgbClr val="FFFFFF"/>
+          </a:solidFill>
+          <a:ln w="9525">
+            <a:solidFill>
+              <a:srgbClr val="D5DEDB"/>
+            </a:solidFill>
+            <a:prstDash val="solid"/>
+          </a:ln>
+        </p:spPr>
+      </p:sp>
+      <p:sp>
+        <p:nvSpPr>
+          <p:cNvPr id="21" name="Text 17"/>
+          <p:cNvSpPr txBox="1"/>
+          <p:nvPr/>
+        </p:nvSpPr>
+        <p:spPr>
+          <a:xfrm>
+            <a:off x="7096658" y="2240280"/>
+            <a:ext cx="457200" cy="411480"/>
+          </a:xfrm>
+          <a:prstGeom prst="rect">
+            <a:avLst/>
+          </a:prstGeom>
+          <a:noFill/>
+          <a:ln/>
+        </p:spPr>
+        <p:txBody>
+          <a:bodyPr wrap="square" lIns="0" tIns="0" rIns="0" bIns="0" rtlCol="0" anchor="t"/>
+          <a:lstStyle/>
+          <a:p>
+            <a:pPr indent="0" marL="0">
+              <a:buNone/>
+            </a:pPr>
+            <a:r>
+              <a:rPr lang="en-US" sz="2200" b="1" dirty="0">
+                <a:solidFill>
+                  <a:srgbClr val="0E7C6B"/>
+                </a:solidFill>
+                <a:latin typeface="Arial" pitchFamily="34" charset="0"/>
+                <a:ea typeface="Arial" pitchFamily="34" charset="-122"/>
+                <a:cs typeface="Arial" pitchFamily="34" charset="-120"/>
+              </a:rPr>
+              <a:t>2</a:t>
+            </a:r>
+            <a:endParaRPr lang="en-US" sz="2200" dirty="0"/>
+          </a:p>
+        </p:txBody>
+      </p:sp>
+      <p:pic>
+        <p:nvPicPr>
+          <p:cNvPr id="22" name="Image 2" descr="preencoded.png">    </p:cNvPr>
+          <p:cNvPicPr>
+            <a:picLocks noChangeAspect="1"/>
+          </p:cNvPicPr>
+          <p:nvPr/>
+        </p:nvPicPr>
+        <p:blipFill>
+          <a:blip r:embed="rId3"/>
+          <a:stretch>
+            <a:fillRect/>
+          </a:stretch>
+        </p:blipFill>
+        <p:spPr>
+          <a:xfrm>
+            <a:off x="8569757" y="2286000"/>
+            <a:ext cx="347472" cy="347472"/>
+          </a:xfrm>
+          <a:prstGeom prst="rect">
+            <a:avLst/>
+          </a:prstGeom>
+        </p:spPr>
+      </p:pic>
+      <p:sp>
+        <p:nvSpPr>
+          <p:cNvPr id="23" name="Text 18"/>
+          <p:cNvSpPr txBox="1"/>
+          <p:nvPr/>
+        </p:nvSpPr>
+        <p:spPr>
+          <a:xfrm>
+            <a:off x="7096658" y="2697480"/>
+            <a:ext cx="1838858" cy="320040"/>
+          </a:xfrm>
+          <a:prstGeom prst="rect">
+            <a:avLst/>
+          </a:prstGeom>
+          <a:noFill/>
+          <a:ln/>
+        </p:spPr>
+        <p:txBody>
+          <a:bodyPr wrap="square" lIns="0" tIns="0" rIns="0" bIns="0" rtlCol="0" anchor="t"/>
+          <a:lstStyle/>
+          <a:p>
+            <a:pPr indent="0" marL="0">
+              <a:buNone/>
+            </a:pPr>
+            <a:r>
+              <a:rPr lang="en-US" sz="1600" b="1" dirty="0">
+                <a:solidFill>
+                  <a:srgbClr val="14232B"/>
+                </a:solidFill>
+                <a:latin typeface="Arial" pitchFamily="34" charset="0"/>
+                <a:ea typeface="Arial" pitchFamily="34" charset="-122"/>
+                <a:cs typeface="Arial" pitchFamily="34" charset="-120"/>
+              </a:rPr>
+              <a:t>Follow up</a:t>
+            </a:r>
+            <a:endParaRPr lang="en-US" sz="1600" dirty="0"/>
+          </a:p>
+        </p:txBody>
+      </p:sp>
+      <p:sp>
+        <p:nvSpPr>
+          <p:cNvPr id="24" name="Text 19"/>
+          <p:cNvSpPr txBox="1"/>
+          <p:nvPr/>
+        </p:nvSpPr>
+        <p:spPr>
+          <a:xfrm>
+            <a:off x="7096658" y="3063240"/>
+            <a:ext cx="1884578" cy="777240"/>
+          </a:xfrm>
+          <a:prstGeom prst="rect">
+            <a:avLst/>
+          </a:prstGeom>
+          <a:noFill/>
+          <a:ln/>
+        </p:spPr>
+        <p:txBody>
+          <a:bodyPr wrap="square" lIns="0" tIns="0" rIns="0" bIns="0" rtlCol="0" anchor="t"/>
+          <a:lstStyle/>
+          <a:p>
+            <a:pPr indent="0" marL="0">
+              <a:buNone/>
+            </a:pPr>
+            <a:r>
+              <a:rPr lang="en-US" sz="1150" dirty="0">
+                <a:solidFill>
+                  <a:srgbClr val="5B6B70"/>
+                </a:solidFill>
+                <a:latin typeface="Arial" pitchFamily="34" charset="0"/>
+                <a:ea typeface="Arial" pitchFamily="34" charset="-122"/>
+                <a:cs typeface="Arial" pitchFamily="34" charset="-120"/>
+              </a:rPr>
+              <a:t>Timed follow-ups and reminders until the patient books or opts out.</a:t>
+            </a:r>
+            <a:endParaRPr lang="en-US" sz="1150" dirty="0"/>
+          </a:p>
+        </p:txBody>
+      </p:sp>
+      <p:sp>
+        <p:nvSpPr>
+          <p:cNvPr id="25" name="Shape 20"/>
+          <p:cNvSpPr/>
+          <p:nvPr/>
+        </p:nvSpPr>
+        <p:spPr>
+          <a:xfrm>
+            <a:off x="9346997" y="2103120"/>
+            <a:ext cx="2296058" cy="1828800"/>
+          </a:xfrm>
+          <a:prstGeom prst="roundRect">
+            <a:avLst>
+              <a:gd name="adj" fmla="val 6000"/>
+            </a:avLst>
+          </a:prstGeom>
+          <a:solidFill>
+            <a:srgbClr val="DCEFEA"/>
+          </a:solidFill>
+          <a:ln w="9525">
+            <a:solidFill>
+              <a:srgbClr val="0E7C6B"/>
+            </a:solidFill>
+            <a:prstDash val="solid"/>
+          </a:ln>
+        </p:spPr>
+      </p:sp>
+      <p:sp>
+        <p:nvSpPr>
+          <p:cNvPr id="26" name="Text 21"/>
+          <p:cNvSpPr txBox="1"/>
+          <p:nvPr/>
+        </p:nvSpPr>
+        <p:spPr>
+          <a:xfrm>
+            <a:off x="9575597" y="2240280"/>
+            <a:ext cx="457200" cy="411480"/>
+          </a:xfrm>
+          <a:prstGeom prst="rect">
+            <a:avLst/>
+          </a:prstGeom>
+          <a:noFill/>
+          <a:ln/>
+        </p:spPr>
+        <p:txBody>
+          <a:bodyPr wrap="square" lIns="0" tIns="0" rIns="0" bIns="0" rtlCol="0" anchor="t"/>
+          <a:lstStyle/>
+          <a:p>
+            <a:pPr indent="0" marL="0">
+              <a:buNone/>
+            </a:pPr>
+            <a:r>
+              <a:rPr lang="en-US" sz="2200" b="1" dirty="0">
+                <a:solidFill>
+                  <a:srgbClr val="0E7C6B"/>
+                </a:solidFill>
+                <a:latin typeface="Arial" pitchFamily="34" charset="0"/>
+                <a:ea typeface="Arial" pitchFamily="34" charset="-122"/>
+                <a:cs typeface="Arial" pitchFamily="34" charset="-120"/>
+              </a:rPr>
+              <a:t>3</a:t>
+            </a:r>
+            <a:endParaRPr lang="en-US" sz="2200" dirty="0"/>
+          </a:p>
+        </p:txBody>
+      </p:sp>
+      <p:pic>
+        <p:nvPicPr>
+          <p:cNvPr id="27" name="Image 3" descr="preencoded.png">    </p:cNvPr>
+          <p:cNvPicPr>
+            <a:picLocks noChangeAspect="1"/>
+          </p:cNvPicPr>
+          <p:nvPr/>
+        </p:nvPicPr>
+        <p:blipFill>
+          <a:blip r:embed="rId4"/>
+          <a:stretch>
+            <a:fillRect/>
+          </a:stretch>
+        </p:blipFill>
+        <p:spPr>
+          <a:xfrm>
+            <a:off x="11048695" y="2286000"/>
+            <a:ext cx="347472" cy="347472"/>
+          </a:xfrm>
+          <a:prstGeom prst="rect">
+            <a:avLst/>
+          </a:prstGeom>
+        </p:spPr>
+      </p:pic>
+      <p:sp>
+        <p:nvSpPr>
+          <p:cNvPr id="28" name="Text 22"/>
+          <p:cNvSpPr txBox="1"/>
+          <p:nvPr/>
+        </p:nvSpPr>
+        <p:spPr>
+          <a:xfrm>
+            <a:off x="9575597" y="2697480"/>
+            <a:ext cx="1838858" cy="320040"/>
+          </a:xfrm>
+          <a:prstGeom prst="rect">
+            <a:avLst/>
+          </a:prstGeom>
+          <a:noFill/>
+          <a:ln/>
+        </p:spPr>
+        <p:txBody>
+          <a:bodyPr wrap="square" lIns="0" tIns="0" rIns="0" bIns="0" rtlCol="0" anchor="t"/>
+          <a:lstStyle/>
+          <a:p>
+            <a:pPr indent="0" marL="0">
+              <a:buNone/>
+            </a:pPr>
+            <a:r>
+              <a:rPr lang="en-US" sz="1600" b="1" dirty="0">
+                <a:solidFill>
+                  <a:srgbClr val="14232B"/>
+                </a:solidFill>
+                <a:latin typeface="Arial" pitchFamily="34" charset="0"/>
+                <a:ea typeface="Arial" pitchFamily="34" charset="-122"/>
+                <a:cs typeface="Arial" pitchFamily="34" charset="-120"/>
+              </a:rPr>
+              <a:t>Recover</a:t>
+            </a:r>
+            <a:endParaRPr lang="en-US" sz="1600" dirty="0"/>
+          </a:p>
+        </p:txBody>
+      </p:sp>
+      <p:sp>
+        <p:nvSpPr>
+          <p:cNvPr id="29" name="Text 23"/>
+          <p:cNvSpPr txBox="1"/>
+          <p:nvPr/>
+        </p:nvSpPr>
+        <p:spPr>
+          <a:xfrm>
+            <a:off x="9575597" y="3063240"/>
+            <a:ext cx="1884578" cy="777240"/>
+          </a:xfrm>
+          <a:prstGeom prst="rect">
+            <a:avLst/>
+          </a:prstGeom>
+          <a:noFill/>
+          <a:ln/>
+        </p:spPr>
+        <p:txBody>
+          <a:bodyPr wrap="square" lIns="0" tIns="0" rIns="0" bIns="0" rtlCol="0" anchor="t"/>
+          <a:lstStyle/>
+          <a:p>
+            <a:pPr indent="0" marL="0">
+              <a:buNone/>
+            </a:pPr>
+            <a:r>
+              <a:rPr lang="en-US" sz="1150" dirty="0">
+                <a:solidFill>
+                  <a:srgbClr val="5B6B70"/>
+                </a:solidFill>
+                <a:latin typeface="Arial" pitchFamily="34" charset="0"/>
+                <a:ea typeface="Arial" pitchFamily="34" charset="-122"/>
+                <a:cs typeface="Arial" pitchFamily="34" charset="-120"/>
+              </a:rPr>
+              <a:t>Missed visits and past patients are invited back where appointment data allows.</a:t>
+            </a:r>
+            <a:endParaRPr lang="en-US" sz="1150" dirty="0"/>
+          </a:p>
+        </p:txBody>
+      </p:sp>
+      <p:sp>
+        <p:nvSpPr>
+          <p:cNvPr id="30" name="Text 24"/>
+          <p:cNvSpPr txBox="1"/>
+          <p:nvPr/>
+        </p:nvSpPr>
+        <p:spPr>
+          <a:xfrm>
+            <a:off x="548640" y="4160520"/>
+            <a:ext cx="5486400" cy="237744"/>
+          </a:xfrm>
+          <a:prstGeom prst="rect">
+            <a:avLst/>
+          </a:prstGeom>
+          <a:noFill/>
+          <a:ln/>
+        </p:spPr>
+        <p:txBody>
+          <a:bodyPr wrap="square" lIns="0" tIns="0" rIns="0" bIns="0" rtlCol="0" anchor="t"/>
+          <a:lstStyle/>
+          <a:p>
+            <a:pPr indent="0" marL="0">
+              <a:buNone/>
+            </a:pPr>
+            <a:r>
+              <a:rPr lang="en-US" sz="1050" b="1" spc="150" kern="0" dirty="0">
+                <a:solidFill>
+                  <a:srgbClr val="0E7C6B"/>
+                </a:solidFill>
+                <a:latin typeface="Arial" pitchFamily="34" charset="0"/>
+                <a:ea typeface="Arial" pitchFamily="34" charset="-122"/>
+                <a:cs typeface="Arial" pitchFamily="34" charset="-120"/>
+              </a:rPr>
+              <a:t>HOW IT WORKS</a:t>
+            </a:r>
+            <a:endParaRPr lang="en-US" sz="1050" dirty="0"/>
+          </a:p>
+        </p:txBody>
+      </p:sp>
+      <p:sp>
+        <p:nvSpPr>
+          <p:cNvPr id="31" name="Shape 25"/>
+          <p:cNvSpPr/>
+          <p:nvPr/>
+        </p:nvSpPr>
+        <p:spPr>
+          <a:xfrm>
+            <a:off x="548640" y="4434840"/>
+            <a:ext cx="1999427" cy="566928"/>
+          </a:xfrm>
+          <a:prstGeom prst="roundRect">
+            <a:avLst>
+              <a:gd name="adj" fmla="val 19355"/>
+            </a:avLst>
+          </a:prstGeom>
+          <a:solidFill>
+            <a:srgbClr val="FFFFFF"/>
+          </a:solidFill>
+          <a:ln w="9525">
+            <a:solidFill>
+              <a:srgbClr val="D5DEDB"/>
+            </a:solidFill>
+            <a:prstDash val="solid"/>
+          </a:ln>
+        </p:spPr>
+      </p:sp>
+      <p:sp>
+        <p:nvSpPr>
+          <p:cNvPr id="32" name="Text 26"/>
+          <p:cNvSpPr txBox="1"/>
+          <p:nvPr/>
+        </p:nvSpPr>
+        <p:spPr>
+          <a:xfrm>
+            <a:off x="658368" y="4434840"/>
+            <a:ext cx="1779971" cy="566928"/>
+          </a:xfrm>
+          <a:prstGeom prst="rect">
+            <a:avLst/>
+          </a:prstGeom>
+          <a:noFill/>
+          <a:ln/>
+        </p:spPr>
+        <p:txBody>
+          <a:bodyPr wrap="square" lIns="0" tIns="0" rIns="0" bIns="0" rtlCol="0" anchor="ctr"/>
+          <a:lstStyle/>
+          <a:p>
+            <a:pPr algn="ctr" indent="0" marL="0">
+              <a:buNone/>
+            </a:pPr>
+            <a:r>
+              <a:rPr lang="en-US" sz="1150" b="1" dirty="0">
+                <a:solidFill>
+                  <a:srgbClr val="14232B"/>
+                </a:solidFill>
+                <a:latin typeface="Arial" pitchFamily="34" charset="0"/>
+                <a:ea typeface="Arial" pitchFamily="34" charset="-122"/>
+                <a:cs typeface="Arial" pitchFamily="34" charset="-120"/>
+              </a:rPr>
+              <a:t>Patient messages on WhatsApp</a:t>
+            </a:r>
+            <a:endParaRPr lang="en-US" sz="1150" dirty="0"/>
+          </a:p>
+        </p:txBody>
+      </p:sp>
+      <p:sp>
+        <p:nvSpPr>
+          <p:cNvPr id="33" name="Shape 27"/>
+          <p:cNvSpPr/>
+          <p:nvPr/>
+        </p:nvSpPr>
+        <p:spPr>
+          <a:xfrm>
+            <a:off x="2584643" y="4718304"/>
+            <a:ext cx="201168" cy="0"/>
+          </a:xfrm>
+          <a:prstGeom prst="line">
+            <a:avLst/>
+          </a:prstGeom>
+          <a:noFill/>
+          <a:ln w="19050">
+            <a:solidFill>
+              <a:srgbClr val="0E7C6B"/>
+            </a:solidFill>
+            <a:prstDash val="solid"/>
+            <a:tailEnd type="triangle"/>
+          </a:ln>
+        </p:spPr>
+      </p:sp>
+      <p:sp>
+        <p:nvSpPr>
+          <p:cNvPr id="34" name="Shape 28"/>
+          <p:cNvSpPr/>
+          <p:nvPr/>
+        </p:nvSpPr>
+        <p:spPr>
+          <a:xfrm>
+            <a:off x="2822387" y="4434840"/>
+            <a:ext cx="1999427" cy="566928"/>
+          </a:xfrm>
+          <a:prstGeom prst="roundRect">
+            <a:avLst>
+              <a:gd name="adj" fmla="val 19355"/>
+            </a:avLst>
+          </a:prstGeom>
+          <a:solidFill>
+            <a:srgbClr val="FFFFFF"/>
+          </a:solidFill>
+          <a:ln w="9525">
+            <a:solidFill>
+              <a:srgbClr val="D5DEDB"/>
+            </a:solidFill>
+            <a:prstDash val="solid"/>
+          </a:ln>
+        </p:spPr>
+      </p:sp>
+      <p:sp>
+        <p:nvSpPr>
+          <p:cNvPr id="35" name="Text 29"/>
+          <p:cNvSpPr txBox="1"/>
+          <p:nvPr/>
+        </p:nvSpPr>
+        <p:spPr>
+          <a:xfrm>
+            <a:off x="2932115" y="4434840"/>
+            <a:ext cx="1779971" cy="566928"/>
+          </a:xfrm>
+          <a:prstGeom prst="rect">
+            <a:avLst/>
+          </a:prstGeom>
+          <a:noFill/>
+          <a:ln/>
+        </p:spPr>
+        <p:txBody>
+          <a:bodyPr wrap="square" lIns="0" tIns="0" rIns="0" bIns="0" rtlCol="0" anchor="ctr"/>
+          <a:lstStyle/>
+          <a:p>
+            <a:pPr algn="ctr" indent="0" marL="0">
+              <a:buNone/>
+            </a:pPr>
+            <a:r>
+              <a:rPr lang="en-US" sz="1150" b="1" dirty="0">
+                <a:solidFill>
+                  <a:srgbClr val="14232B"/>
+                </a:solidFill>
+                <a:latin typeface="Arial" pitchFamily="34" charset="0"/>
+                <a:ea typeface="Arial" pitchFamily="34" charset="-122"/>
+                <a:cs typeface="Arial" pitchFamily="34" charset="-120"/>
+              </a:rPr>
+              <a:t>Approved answers and a few questions</a:t>
+            </a:r>
+            <a:endParaRPr lang="en-US" sz="1150" dirty="0"/>
+          </a:p>
+        </p:txBody>
+      </p:sp>
+      <p:sp>
+        <p:nvSpPr>
+          <p:cNvPr id="36" name="Shape 30"/>
+          <p:cNvSpPr/>
+          <p:nvPr/>
+        </p:nvSpPr>
+        <p:spPr>
+          <a:xfrm>
+            <a:off x="4858390" y="4718304"/>
+            <a:ext cx="201168" cy="0"/>
+          </a:xfrm>
+          <a:prstGeom prst="line">
+            <a:avLst/>
+          </a:prstGeom>
+          <a:noFill/>
+          <a:ln w="19050">
+            <a:solidFill>
+              <a:srgbClr val="0E7C6B"/>
+            </a:solidFill>
+            <a:prstDash val="solid"/>
+            <a:tailEnd type="triangle"/>
+          </a:ln>
+        </p:spPr>
+      </p:sp>
+      <p:sp>
+        <p:nvSpPr>
+          <p:cNvPr id="37" name="Shape 31"/>
+          <p:cNvSpPr/>
+          <p:nvPr/>
+        </p:nvSpPr>
+        <p:spPr>
+          <a:xfrm>
+            <a:off x="5096134" y="4434840"/>
+            <a:ext cx="1999427" cy="566928"/>
+          </a:xfrm>
+          <a:prstGeom prst="roundRect">
+            <a:avLst>
+              <a:gd name="adj" fmla="val 19355"/>
+            </a:avLst>
+          </a:prstGeom>
+          <a:solidFill>
+            <a:srgbClr val="FFFFFF"/>
+          </a:solidFill>
+          <a:ln w="9525">
+            <a:solidFill>
+              <a:srgbClr val="D5DEDB"/>
+            </a:solidFill>
+            <a:prstDash val="solid"/>
+          </a:ln>
+        </p:spPr>
+      </p:sp>
+      <p:sp>
+        <p:nvSpPr>
+          <p:cNvPr id="38" name="Text 32"/>
+          <p:cNvSpPr txBox="1"/>
+          <p:nvPr/>
+        </p:nvSpPr>
+        <p:spPr>
+          <a:xfrm>
+            <a:off x="5205862" y="4434840"/>
+            <a:ext cx="1779971" cy="566928"/>
+          </a:xfrm>
+          <a:prstGeom prst="rect">
+            <a:avLst/>
+          </a:prstGeom>
+          <a:noFill/>
+          <a:ln/>
+        </p:spPr>
+        <p:txBody>
+          <a:bodyPr wrap="square" lIns="0" tIns="0" rIns="0" bIns="0" rtlCol="0" anchor="ctr"/>
+          <a:lstStyle/>
+          <a:p>
+            <a:pPr algn="ctr" indent="0" marL="0">
+              <a:buNone/>
+            </a:pPr>
+            <a:r>
+              <a:rPr lang="en-US" sz="1150" b="1" dirty="0">
+                <a:solidFill>
+                  <a:srgbClr val="14232B"/>
+                </a:solidFill>
+                <a:latin typeface="Arial" pitchFamily="34" charset="0"/>
+                <a:ea typeface="Arial" pitchFamily="34" charset="-122"/>
+                <a:cs typeface="Arial" pitchFamily="34" charset="-120"/>
+              </a:rPr>
+              <a:t>Follow-ups if not booked</a:t>
+            </a:r>
+            <a:endParaRPr lang="en-US" sz="1150" dirty="0"/>
+          </a:p>
+        </p:txBody>
+      </p:sp>
+      <p:sp>
+        <p:nvSpPr>
+          <p:cNvPr id="39" name="Shape 33"/>
+          <p:cNvSpPr/>
+          <p:nvPr/>
+        </p:nvSpPr>
+        <p:spPr>
+          <a:xfrm>
+            <a:off x="7132137" y="4718304"/>
+            <a:ext cx="201168" cy="0"/>
+          </a:xfrm>
+          <a:prstGeom prst="line">
+            <a:avLst/>
+          </a:prstGeom>
+          <a:noFill/>
+          <a:ln w="19050">
+            <a:solidFill>
+              <a:srgbClr val="0E7C6B"/>
+            </a:solidFill>
+            <a:prstDash val="solid"/>
+            <a:tailEnd type="triangle"/>
+          </a:ln>
+        </p:spPr>
+      </p:sp>
+      <p:sp>
+        <p:nvSpPr>
+          <p:cNvPr id="40" name="Shape 34"/>
+          <p:cNvSpPr/>
+          <p:nvPr/>
+        </p:nvSpPr>
+        <p:spPr>
+          <a:xfrm>
+            <a:off x="7369881" y="4434840"/>
+            <a:ext cx="1999427" cy="566928"/>
+          </a:xfrm>
+          <a:prstGeom prst="roundRect">
+            <a:avLst>
+              <a:gd name="adj" fmla="val 19355"/>
+            </a:avLst>
+          </a:prstGeom>
+          <a:solidFill>
+            <a:srgbClr val="FFFFFF"/>
+          </a:solidFill>
+          <a:ln w="9525">
+            <a:solidFill>
+              <a:srgbClr val="D5DEDB"/>
+            </a:solidFill>
+            <a:prstDash val="solid"/>
+          </a:ln>
+        </p:spPr>
+      </p:sp>
+      <p:sp>
+        <p:nvSpPr>
+          <p:cNvPr id="41" name="Text 35"/>
+          <p:cNvSpPr txBox="1"/>
+          <p:nvPr/>
+        </p:nvSpPr>
+        <p:spPr>
+          <a:xfrm>
+            <a:off x="7479609" y="4434840"/>
+            <a:ext cx="1779971" cy="566928"/>
+          </a:xfrm>
+          <a:prstGeom prst="rect">
+            <a:avLst/>
+          </a:prstGeom>
+          <a:noFill/>
+          <a:ln/>
+        </p:spPr>
+        <p:txBody>
+          <a:bodyPr wrap="square" lIns="0" tIns="0" rIns="0" bIns="0" rtlCol="0" anchor="ctr"/>
+          <a:lstStyle/>
+          <a:p>
+            <a:pPr algn="ctr" indent="0" marL="0">
+              <a:buNone/>
+            </a:pPr>
+            <a:r>
+              <a:rPr lang="en-US" sz="1150" b="1" dirty="0">
+                <a:solidFill>
+                  <a:srgbClr val="14232B"/>
+                </a:solidFill>
+                <a:latin typeface="Arial" pitchFamily="34" charset="0"/>
+                <a:ea typeface="Arial" pitchFamily="34" charset="-122"/>
+                <a:cs typeface="Arial" pitchFamily="34" charset="-120"/>
+              </a:rPr>
+              <a:t>Booking link or staff call</a:t>
+            </a:r>
+            <a:endParaRPr lang="en-US" sz="1150" dirty="0"/>
+          </a:p>
+        </p:txBody>
+      </p:sp>
+      <p:sp>
+        <p:nvSpPr>
+          <p:cNvPr id="42" name="Shape 36"/>
+          <p:cNvSpPr/>
+          <p:nvPr/>
+        </p:nvSpPr>
+        <p:spPr>
+          <a:xfrm>
+            <a:off x="9405884" y="4718304"/>
+            <a:ext cx="201168" cy="0"/>
+          </a:xfrm>
+          <a:prstGeom prst="line">
+            <a:avLst/>
+          </a:prstGeom>
+          <a:noFill/>
+          <a:ln w="19050">
+            <a:solidFill>
+              <a:srgbClr val="0E7C6B"/>
+            </a:solidFill>
+            <a:prstDash val="solid"/>
+            <a:tailEnd type="triangle"/>
+          </a:ln>
+        </p:spPr>
+      </p:sp>
+      <p:sp>
+        <p:nvSpPr>
+          <p:cNvPr id="43" name="Shape 37"/>
+          <p:cNvSpPr/>
+          <p:nvPr/>
+        </p:nvSpPr>
+        <p:spPr>
+          <a:xfrm>
+            <a:off x="9643628" y="4434840"/>
+            <a:ext cx="1999427" cy="566928"/>
+          </a:xfrm>
+          <a:prstGeom prst="roundRect">
+            <a:avLst>
+              <a:gd name="adj" fmla="val 19355"/>
+            </a:avLst>
+          </a:prstGeom>
+          <a:solidFill>
+            <a:srgbClr val="14232B"/>
+          </a:solidFill>
+          <a:ln w="9525">
+            <a:solidFill>
+              <a:srgbClr val="14232B"/>
+            </a:solidFill>
+            <a:prstDash val="solid"/>
+          </a:ln>
+        </p:spPr>
+      </p:sp>
+      <p:sp>
+        <p:nvSpPr>
+          <p:cNvPr id="44" name="Text 38"/>
+          <p:cNvSpPr txBox="1"/>
+          <p:nvPr/>
+        </p:nvSpPr>
+        <p:spPr>
+          <a:xfrm>
+            <a:off x="9753356" y="4434840"/>
+            <a:ext cx="1779971" cy="566928"/>
+          </a:xfrm>
+          <a:prstGeom prst="rect">
+            <a:avLst/>
+          </a:prstGeom>
+          <a:noFill/>
+          <a:ln/>
+        </p:spPr>
+        <p:txBody>
+          <a:bodyPr wrap="square" lIns="0" tIns="0" rIns="0" bIns="0" rtlCol="0" anchor="ctr"/>
+          <a:lstStyle/>
+          <a:p>
+            <a:pPr algn="ctr" indent="0" marL="0">
+              <a:buNone/>
+            </a:pPr>
+            <a:r>
+              <a:rPr lang="en-US" sz="1150" b="1" dirty="0">
+                <a:solidFill>
+                  <a:srgbClr val="FFFFFF"/>
+                </a:solidFill>
+                <a:latin typeface="Arial" pitchFamily="34" charset="0"/>
+                <a:ea typeface="Arial" pitchFamily="34" charset="-122"/>
+                <a:cs typeface="Arial" pitchFamily="34" charset="-120"/>
+              </a:rPr>
+              <a:t>Status tracked for every enquiry</a:t>
+            </a:r>
+            <a:endParaRPr lang="en-US" sz="1150" dirty="0"/>
+          </a:p>
+        </p:txBody>
+      </p:sp>
+      <p:sp>
+        <p:nvSpPr>
+          <p:cNvPr id="45" name="Text 39"/>
+          <p:cNvSpPr txBox="1"/>
+          <p:nvPr/>
+        </p:nvSpPr>
+        <p:spPr>
+          <a:xfrm>
+            <a:off x="548640" y="5230368"/>
+            <a:ext cx="5486400" cy="237744"/>
+          </a:xfrm>
+          <a:prstGeom prst="rect">
+            <a:avLst/>
+          </a:prstGeom>
+          <a:noFill/>
+          <a:ln/>
+        </p:spPr>
+        <p:txBody>
+          <a:bodyPr wrap="square" lIns="0" tIns="0" rIns="0" bIns="0" rtlCol="0" anchor="t"/>
+          <a:lstStyle/>
+          <a:p>
+            <a:pPr indent="0" marL="0">
+              <a:buNone/>
+            </a:pPr>
+            <a:r>
+              <a:rPr lang="en-US" sz="1050" b="1" spc="150" kern="0" dirty="0">
+                <a:solidFill>
+                  <a:srgbClr val="0E7C6B"/>
+                </a:solidFill>
+                <a:latin typeface="Arial" pitchFamily="34" charset="0"/>
+                <a:ea typeface="Arial" pitchFamily="34" charset="-122"/>
+                <a:cs typeface="Arial" pitchFamily="34" charset="-120"/>
+              </a:rPr>
+              <a:t>WHAT CHANGES FOR THE CLINIC</a:t>
+            </a:r>
+            <a:endParaRPr lang="en-US" sz="1050" dirty="0"/>
+          </a:p>
+        </p:txBody>
+      </p:sp>
+      <p:sp>
+        <p:nvSpPr>
+          <p:cNvPr id="46" name="Shape 40"/>
+          <p:cNvSpPr/>
+          <p:nvPr/>
+        </p:nvSpPr>
+        <p:spPr>
+          <a:xfrm>
+            <a:off x="548640" y="5504688"/>
+            <a:ext cx="2636444" cy="640080"/>
+          </a:xfrm>
+          <a:prstGeom prst="roundRect">
+            <a:avLst>
+              <a:gd name="adj" fmla="val 17143"/>
+            </a:avLst>
+          </a:prstGeom>
+          <a:solidFill>
+            <a:srgbClr val="DCEFEA"/>
+          </a:solidFill>
+          <a:ln/>
+        </p:spPr>
+      </p:sp>
+      <p:pic>
+        <p:nvPicPr>
+          <p:cNvPr id="47" name="Image 4" descr="preencoded.png">    </p:cNvPr>
+          <p:cNvPicPr>
+            <a:picLocks noChangeAspect="1"/>
+          </p:cNvPicPr>
+          <p:nvPr/>
+        </p:nvPicPr>
+        <p:blipFill>
+          <a:blip r:embed="rId5"/>
+          <a:stretch>
+            <a:fillRect/>
+          </a:stretch>
+        </p:blipFill>
+        <p:spPr>
+          <a:xfrm>
+            <a:off x="731520" y="5669280"/>
+            <a:ext cx="310896" cy="310896"/>
+          </a:xfrm>
+          <a:prstGeom prst="rect">
+            <a:avLst/>
+          </a:prstGeom>
+        </p:spPr>
+      </p:pic>
+      <p:sp>
+        <p:nvSpPr>
+          <p:cNvPr id="48" name="Text 41"/>
+          <p:cNvSpPr txBox="1"/>
+          <p:nvPr/>
+        </p:nvSpPr>
+        <p:spPr>
+          <a:xfrm>
+            <a:off x="1170432" y="5504688"/>
+            <a:ext cx="1859204" cy="640080"/>
+          </a:xfrm>
+          <a:prstGeom prst="rect">
+            <a:avLst/>
+          </a:prstGeom>
+          <a:noFill/>
+          <a:ln/>
+        </p:spPr>
+        <p:txBody>
+          <a:bodyPr wrap="square" lIns="0" tIns="0" rIns="0" bIns="0" rtlCol="0" anchor="ctr"/>
+          <a:lstStyle/>
+          <a:p>
+            <a:pPr indent="0" marL="0">
+              <a:buNone/>
+            </a:pPr>
+            <a:r>
+              <a:rPr lang="en-US" sz="1200" b="1" dirty="0">
+                <a:solidFill>
+                  <a:srgbClr val="14232B"/>
+                </a:solidFill>
+                <a:latin typeface="Arial" pitchFamily="34" charset="0"/>
+                <a:ea typeface="Arial" pitchFamily="34" charset="-122"/>
+                <a:cs typeface="Arial" pitchFamily="34" charset="-120"/>
+              </a:rPr>
+              <a:t>No enquiry goes unanswered</a:t>
+            </a:r>
+            <a:endParaRPr lang="en-US" sz="1200" dirty="0"/>
+          </a:p>
+        </p:txBody>
+      </p:sp>
+      <p:sp>
+        <p:nvSpPr>
+          <p:cNvPr id="49" name="Shape 42"/>
+          <p:cNvSpPr/>
+          <p:nvPr/>
+        </p:nvSpPr>
+        <p:spPr>
+          <a:xfrm>
+            <a:off x="3367964" y="5504688"/>
+            <a:ext cx="2636444" cy="640080"/>
+          </a:xfrm>
+          <a:prstGeom prst="roundRect">
+            <a:avLst>
+              <a:gd name="adj" fmla="val 17143"/>
+            </a:avLst>
+          </a:prstGeom>
+          <a:solidFill>
+            <a:srgbClr val="DCEFEA"/>
+          </a:solidFill>
+          <a:ln/>
+        </p:spPr>
+      </p:sp>
+      <p:pic>
+        <p:nvPicPr>
+          <p:cNvPr id="50" name="Image 5" descr="preencoded.png">    </p:cNvPr>
+          <p:cNvPicPr>
+            <a:picLocks noChangeAspect="1"/>
+          </p:cNvPicPr>
+          <p:nvPr/>
+        </p:nvPicPr>
+        <p:blipFill>
+          <a:blip r:embed="rId6"/>
+          <a:stretch>
+            <a:fillRect/>
+          </a:stretch>
+        </p:blipFill>
+        <p:spPr>
+          <a:xfrm>
+            <a:off x="3550844" y="5669280"/>
+            <a:ext cx="310896" cy="310896"/>
+          </a:xfrm>
+          <a:prstGeom prst="rect">
+            <a:avLst/>
+          </a:prstGeom>
+        </p:spPr>
+      </p:pic>
+      <p:sp>
+        <p:nvSpPr>
+          <p:cNvPr id="51" name="Text 43"/>
+          <p:cNvSpPr txBox="1"/>
+          <p:nvPr/>
+        </p:nvSpPr>
+        <p:spPr>
+          <a:xfrm>
+            <a:off x="3989756" y="5504688"/>
+            <a:ext cx="1859204" cy="640080"/>
+          </a:xfrm>
+          <a:prstGeom prst="rect">
+            <a:avLst/>
+          </a:prstGeom>
+          <a:noFill/>
+          <a:ln/>
+        </p:spPr>
+        <p:txBody>
+          <a:bodyPr wrap="square" lIns="0" tIns="0" rIns="0" bIns="0" rtlCol="0" anchor="ctr"/>
+          <a:lstStyle/>
+          <a:p>
+            <a:pPr indent="0" marL="0">
+              <a:buNone/>
+            </a:pPr>
+            <a:r>
+              <a:rPr lang="en-US" sz="1200" b="1" dirty="0">
+                <a:solidFill>
+                  <a:srgbClr val="14232B"/>
+                </a:solidFill>
+                <a:latin typeface="Arial" pitchFamily="34" charset="0"/>
+                <a:ea typeface="Arial" pitchFamily="34" charset="-122"/>
+                <a:cs typeface="Arial" pitchFamily="34" charset="-120"/>
+              </a:rPr>
+              <a:t>Follow-up happens without staff chasing</a:t>
+            </a:r>
+            <a:endParaRPr lang="en-US" sz="1200" dirty="0"/>
+          </a:p>
+        </p:txBody>
+      </p:sp>
+      <p:sp>
+        <p:nvSpPr>
+          <p:cNvPr id="52" name="Shape 44"/>
+          <p:cNvSpPr/>
+          <p:nvPr/>
+        </p:nvSpPr>
+        <p:spPr>
+          <a:xfrm>
+            <a:off x="6187288" y="5504688"/>
+            <a:ext cx="2636444" cy="640080"/>
+          </a:xfrm>
+          <a:prstGeom prst="roundRect">
+            <a:avLst>
+              <a:gd name="adj" fmla="val 17143"/>
+            </a:avLst>
+          </a:prstGeom>
+          <a:solidFill>
+            <a:srgbClr val="DCEFEA"/>
+          </a:solidFill>
+          <a:ln/>
+        </p:spPr>
+      </p:sp>
+      <p:pic>
+        <p:nvPicPr>
+          <p:cNvPr id="53" name="Image 6" descr="preencoded.png">    </p:cNvPr>
+          <p:cNvPicPr>
+            <a:picLocks noChangeAspect="1"/>
+          </p:cNvPicPr>
+          <p:nvPr/>
+        </p:nvPicPr>
+        <p:blipFill>
+          <a:blip r:embed="rId7"/>
+          <a:stretch>
+            <a:fillRect/>
+          </a:stretch>
+        </p:blipFill>
+        <p:spPr>
+          <a:xfrm>
+            <a:off x="6370168" y="5669280"/>
+            <a:ext cx="310896" cy="310896"/>
+          </a:xfrm>
+          <a:prstGeom prst="rect">
+            <a:avLst/>
+          </a:prstGeom>
+        </p:spPr>
+      </p:pic>
+      <p:sp>
+        <p:nvSpPr>
+          <p:cNvPr id="54" name="Text 45"/>
+          <p:cNvSpPr txBox="1"/>
+          <p:nvPr/>
+        </p:nvSpPr>
+        <p:spPr>
+          <a:xfrm>
+            <a:off x="6809080" y="5504688"/>
+            <a:ext cx="1859204" cy="640080"/>
+          </a:xfrm>
+          <a:prstGeom prst="rect">
+            <a:avLst/>
+          </a:prstGeom>
+          <a:noFill/>
+          <a:ln/>
+        </p:spPr>
+        <p:txBody>
+          <a:bodyPr wrap="square" lIns="0" tIns="0" rIns="0" bIns="0" rtlCol="0" anchor="ctr"/>
+          <a:lstStyle/>
+          <a:p>
+            <a:pPr indent="0" marL="0">
+              <a:buNone/>
+            </a:pPr>
+            <a:r>
+              <a:rPr lang="en-US" sz="1200" b="1" dirty="0">
+                <a:solidFill>
+                  <a:srgbClr val="14232B"/>
+                </a:solidFill>
+                <a:latin typeface="Arial" pitchFamily="34" charset="0"/>
+                <a:ea typeface="Arial" pitchFamily="34" charset="-122"/>
+                <a:cs typeface="Arial" pitchFamily="34" charset="-120"/>
+              </a:rPr>
+              <a:t>Fewer missed bookings left unrecovered</a:t>
+            </a:r>
+            <a:endParaRPr lang="en-US" sz="1200" dirty="0"/>
+          </a:p>
+        </p:txBody>
+      </p:sp>
+      <p:sp>
+        <p:nvSpPr>
+          <p:cNvPr id="55" name="Shape 46"/>
+          <p:cNvSpPr/>
+          <p:nvPr/>
+        </p:nvSpPr>
+        <p:spPr>
+          <a:xfrm>
+            <a:off x="9006611" y="5504688"/>
+            <a:ext cx="2636444" cy="640080"/>
+          </a:xfrm>
+          <a:prstGeom prst="roundRect">
+            <a:avLst>
+              <a:gd name="adj" fmla="val 17143"/>
+            </a:avLst>
+          </a:prstGeom>
+          <a:solidFill>
+            <a:srgbClr val="DCEFEA"/>
+          </a:solidFill>
+          <a:ln/>
+        </p:spPr>
+      </p:sp>
+      <p:pic>
+        <p:nvPicPr>
+          <p:cNvPr id="56" name="Image 7" descr="preencoded.png">    </p:cNvPr>
+          <p:cNvPicPr>
+            <a:picLocks noChangeAspect="1"/>
+          </p:cNvPicPr>
+          <p:nvPr/>
+        </p:nvPicPr>
+        <p:blipFill>
+          <a:blip r:embed="rId8"/>
+          <a:stretch>
+            <a:fillRect/>
+          </a:stretch>
+        </p:blipFill>
+        <p:spPr>
+          <a:xfrm>
+            <a:off x="9189491" y="5669280"/>
+            <a:ext cx="310896" cy="310896"/>
+          </a:xfrm>
+          <a:prstGeom prst="rect">
+            <a:avLst/>
+          </a:prstGeom>
+        </p:spPr>
+      </p:pic>
+      <p:sp>
+        <p:nvSpPr>
+          <p:cNvPr id="57" name="Text 47"/>
+          <p:cNvSpPr txBox="1"/>
+          <p:nvPr/>
+        </p:nvSpPr>
+        <p:spPr>
+          <a:xfrm>
+            <a:off x="9628403" y="5504688"/>
+            <a:ext cx="1859204" cy="640080"/>
+          </a:xfrm>
+          <a:prstGeom prst="rect">
+            <a:avLst/>
+          </a:prstGeom>
+          <a:noFill/>
+          <a:ln/>
+        </p:spPr>
+        <p:txBody>
+          <a:bodyPr wrap="square" lIns="0" tIns="0" rIns="0" bIns="0" rtlCol="0" anchor="ctr"/>
+          <a:lstStyle/>
+          <a:p>
+            <a:pPr indent="0" marL="0">
+              <a:buNone/>
+            </a:pPr>
+            <a:r>
+              <a:rPr lang="en-US" sz="1200" b="1" dirty="0">
+                <a:solidFill>
+                  <a:srgbClr val="14232B"/>
+                </a:solidFill>
+                <a:latin typeface="Arial" pitchFamily="34" charset="0"/>
+                <a:ea typeface="Arial" pitchFamily="34" charset="-122"/>
+                <a:cs typeface="Arial" pitchFamily="34" charset="-120"/>
+              </a:rPr>
+              <a:t>A clear view of every patient's status</a:t>
+            </a:r>
+            <a:endParaRPr lang="en-US" sz="1200" dirty="0"/>
+          </a:p>
+        </p:txBody>
+      </p:sp>
+    </p:spTree>
+  </p:cSld>
+  <p:clrMapOvr>
+    <a:masterClrMapping/>
+  </p:clrMapOvr>
+</p:sld>
+</file>
+
+<file path=ppt/slides/slide3.xml><?xml version="1.0" encoding="utf-8"?>
+<p:sld xmlns:a="http://schemas.openxmlformats.org/drawingml/2006/main" xmlns:r="http://schemas.openxmlformats.org/officeDocument/2006/relationships" xmlns:p="http://schemas.openxmlformats.org/presentationml/2006/main">
+  <p:cSld name="Slide 3">
+    <p:bg>
+      <p:bgPr>
+        <a:solidFill>
+          <a:srgbClr val="F6F8F7"/>
+        </a:solidFill>
+      </p:bgPr>
+    </p:bg>
+    <p:spTree>
+      <p:nvGrpSpPr>
+        <p:cNvPr id="1" name=""/>
+        <p:cNvGrpSpPr/>
+        <p:nvPr/>
+      </p:nvGrpSpPr>
+      <p:grpSpPr>
+        <a:xfrm>
+          <a:off x="0" y="0"/>
+          <a:ext cx="0" cy="0"/>
+          <a:chOff x="0" y="0"/>
+          <a:chExt cx="0" cy="0"/>
+        </a:xfrm>
+      </p:grpSpPr>
+      <p:pic>
+        <p:nvPicPr>
+          <p:cNvPr id="2" name="Image 0" descr="preencoded.png">    </p:cNvPr>
+          <p:cNvPicPr>
+            <a:picLocks noChangeAspect="1"/>
+          </p:cNvPicPr>
+          <p:nvPr/>
+        </p:nvPicPr>
+        <p:blipFill>
+          <a:blip r:embed="rId1"/>
+          <a:stretch>
+            <a:fillRect/>
+          </a:stretch>
+        </p:blipFill>
+        <p:spPr>
+          <a:xfrm>
+            <a:off x="10042855" y="384048"/>
+            <a:ext cx="1600200" cy="304800"/>
+          </a:xfrm>
+          <a:prstGeom prst="rect">
+            <a:avLst/>
+          </a:prstGeom>
+        </p:spPr>
+      </p:pic>
+      <p:sp>
+        <p:nvSpPr>
+          <p:cNvPr id="3" name="Text 0"/>
+          <p:cNvSpPr txBox="1"/>
+          <p:nvPr/>
+        </p:nvSpPr>
+        <p:spPr>
+          <a:xfrm>
+            <a:off x="548640" y="347472"/>
+            <a:ext cx="8229600" cy="256032"/>
+          </a:xfrm>
+          <a:prstGeom prst="rect">
+            <a:avLst/>
+          </a:prstGeom>
+          <a:noFill/>
+          <a:ln/>
+        </p:spPr>
+        <p:txBody>
+          <a:bodyPr wrap="square" lIns="0" tIns="0" rIns="0" bIns="0" rtlCol="0" anchor="t"/>
+          <a:lstStyle/>
+          <a:p>
+            <a:pPr indent="0" marL="0">
+              <a:buNone/>
+            </a:pPr>
+            <a:r>
+              <a:rPr lang="en-US" sz="1100" b="1" spc="150" kern="0" dirty="0">
+                <a:solidFill>
+                  <a:srgbClr val="0E7C6B"/>
+                </a:solidFill>
+                <a:latin typeface="Arial" pitchFamily="34" charset="0"/>
+                <a:ea typeface="Arial" pitchFamily="34" charset="-122"/>
+                <a:cs typeface="Arial" pitchFamily="34" charset="-120"/>
+              </a:rPr>
+              <a:t>PROPOSAL FOR DR. AISHWARYA ARUN  ·  PRICING AND NEXT STEPS</a:t>
+            </a:r>
+            <a:endParaRPr lang="en-US" sz="1100" dirty="0"/>
+          </a:p>
+        </p:txBody>
+      </p:sp>
+      <p:sp>
+        <p:nvSpPr>
+          <p:cNvPr id="4" name="Text 1"/>
+          <p:cNvSpPr txBox="1"/>
+          <p:nvPr/>
+        </p:nvSpPr>
+        <p:spPr>
+          <a:xfrm>
+            <a:off x="548640" y="621792"/>
+            <a:ext cx="9144000" cy="548640"/>
+          </a:xfrm>
+          <a:prstGeom prst="rect">
+            <a:avLst/>
+          </a:prstGeom>
+          <a:noFill/>
+          <a:ln/>
+        </p:spPr>
+        <p:txBody>
+          <a:bodyPr wrap="square" lIns="0" tIns="0" rIns="0" bIns="0" rtlCol="0" anchor="t"/>
+          <a:lstStyle/>
+          <a:p>
+            <a:pPr indent="0" marL="0">
+              <a:buNone/>
+            </a:pPr>
+            <a:r>
+              <a:rPr lang="en-US" sz="2800" b="1" dirty="0">
+                <a:solidFill>
+                  <a:srgbClr val="14232B"/>
+                </a:solidFill>
+                <a:latin typeface="Arial" pitchFamily="34" charset="0"/>
+                <a:ea typeface="Arial" pitchFamily="34" charset="-122"/>
+                <a:cs typeface="Arial" pitchFamily="34" charset="-120"/>
+              </a:rPr>
+              <a:t>Your pilot price and clear scope</a:t>
+            </a:r>
+            <a:endParaRPr lang="en-US" sz="2800" dirty="0"/>
+          </a:p>
+        </p:txBody>
+      </p:sp>
+      <p:sp>
+        <p:nvSpPr>
+          <p:cNvPr id="5" name="Shape 2"/>
+          <p:cNvSpPr/>
+          <p:nvPr/>
+        </p:nvSpPr>
+        <p:spPr>
+          <a:xfrm>
+            <a:off x="548640" y="6355080"/>
+            <a:ext cx="11094415" cy="0"/>
+          </a:xfrm>
+          <a:prstGeom prst="line">
+            <a:avLst/>
+          </a:prstGeom>
+          <a:noFill/>
+          <a:ln w="9525">
+            <a:solidFill>
+              <a:srgbClr val="D5DEDB"/>
+            </a:solidFill>
+            <a:prstDash val="solid"/>
+          </a:ln>
+        </p:spPr>
+      </p:sp>
+      <p:sp>
+        <p:nvSpPr>
+          <p:cNvPr id="6" name="Text 3"/>
+          <p:cNvSpPr txBox="1"/>
+          <p:nvPr/>
+        </p:nvSpPr>
+        <p:spPr>
+          <a:xfrm>
+            <a:off x="548640" y="6437376"/>
+            <a:ext cx="8229600" cy="237744"/>
+          </a:xfrm>
+          <a:prstGeom prst="rect">
+            <a:avLst/>
+          </a:prstGeom>
+          <a:noFill/>
+          <a:ln/>
+        </p:spPr>
+        <p:txBody>
+          <a:bodyPr wrap="square" lIns="0" tIns="0" rIns="0" bIns="0" rtlCol="0" anchor="ctr"/>
+          <a:lstStyle/>
+          <a:p>
+            <a:pPr indent="0" marL="0">
+              <a:buNone/>
+            </a:pPr>
+            <a:r>
               <a:rPr lang="en-US" sz="1000" b="1" dirty="0">
                 <a:solidFill>
-                  <a:srgbClr val="8F5A0E"/>
-                </a:solidFill>
-                <a:latin typeface="Arial" pitchFamily="34" charset="0"/>
-                <a:ea typeface="Arial" pitchFamily="34" charset="-122"/>
-                <a:cs typeface="Arial" pitchFamily="34" charset="-120"/>
-              </a:rPr>
-              <a:t>[Clinic name]</a:t>
+                  <a:srgbClr val="5B6B70"/>
+                </a:solidFill>
+                <a:latin typeface="Arial" pitchFamily="34" charset="0"/>
+                <a:ea typeface="Arial" pitchFamily="34" charset="-122"/>
+                <a:cs typeface="Arial" pitchFamily="34" charset="-120"/>
+              </a:rPr>
+              <a:t>Prepared for  </a:t>
+            </a:r>
+            <a:pPr indent="0" marL="0">
+              <a:buNone/>
+            </a:pPr>
+            <a:r>
+              <a:rPr lang="en-US" sz="1000" dirty="0">
+                <a:solidFill>
+                  <a:srgbClr val="5B6B70"/>
+                </a:solidFill>
+                <a:latin typeface="Arial" pitchFamily="34" charset="0"/>
+                <a:ea typeface="Arial" pitchFamily="34" charset="-122"/>
+                <a:cs typeface="Arial" pitchFamily="34" charset="-120"/>
+              </a:rPr>
+              <a:t>Dr. Aishwarya Arun  ·  </a:t>
+            </a:r>
+            <a:pPr indent="0" marL="0">
+              <a:buNone/>
+            </a:pPr>
+            <a:r>
+              <a:rPr lang="en-US" sz="1000" dirty="0">
+                <a:solidFill>
+                  <a:srgbClr val="5B6B70"/>
+                </a:solidFill>
+                <a:latin typeface="Arial" pitchFamily="34" charset="0"/>
+                <a:ea typeface="Arial" pitchFamily="34" charset="-122"/>
+                <a:cs typeface="Arial" pitchFamily="34" charset="-120"/>
+              </a:rPr>
+              <a:t>Kannan Prime Dental</a:t>
             </a:r>
             <a:pPr indent="0" marL="0">
               <a:buNone/>

</xml_diff>